<commit_message>
Improve presentation storyline and ELK scoring details
</commit_message>
<xml_diff>
--- a/presentation/cyber_log_attack_detection_overview.pptx
+++ b/presentation/cyber_log_attack_detection_overview.pptx
@@ -18,6 +18,10 @@
     <p:sldId id="266" r:id="rId17"/>
     <p:sldId id="267" r:id="rId18"/>
     <p:sldId id="268" r:id="rId19"/>
+    <p:sldId id="269" r:id="rId20"/>
+    <p:sldId id="270" r:id="rId21"/>
+    <p:sldId id="271" r:id="rId22"/>
+    <p:sldId id="272" r:id="rId23"/>
   </p:sldIdLst>
   <p:sldSz cx="12191695" cy="6858000" type="screen4x3"/>
   <p:notesSz cx="6858000" cy="9144000"/>
@@ -3480,7 +3484,7 @@
               </a:defRPr>
             </a:pPr>
             <a:r>
-              <a:t>SSH, web-server, and firewall attack detection with machine learning</a:t>
+              <a:t>From infrastructure logs to ML-assisted security triage</a:t>
             </a:r>
           </a:p>
         </p:txBody>
@@ -3593,7 +3597,7 @@
               </a:defRPr>
             </a:pPr>
             <a:r>
-              <a:t>A two-pass ML pipeline: first detect attack vs normal, then classify attack type with source-specific specialists.</a:t>
+              <a:t>A practical pipeline that collects SSH, web, and firewall logs, turns them into searchable events, and scores them with machine learning.</a:t>
             </a:r>
           </a:p>
         </p:txBody>
@@ -3617,7 +3621,7 @@
           </a:solidFill>
           <a:ln w="19050">
             <a:solidFill>
-              <a:srgbClr val="2A6F97"/>
+              <a:srgbClr val="CC5048"/>
             </a:solidFill>
           </a:ln>
         </p:spPr>
@@ -3668,12 +3672,12 @@
             <a:pPr>
               <a:defRPr b="1" sz="1400">
                 <a:solidFill>
-                  <a:srgbClr val="2A6F97"/>
-                </a:solidFill>
-              </a:defRPr>
-            </a:pPr>
-            <a:r>
-              <a:t>Data</a:t>
+                  <a:srgbClr val="CC5048"/>
+                </a:solidFill>
+              </a:defRPr>
+            </a:pPr>
+            <a:r>
+              <a:t>Why</a:t>
             </a:r>
           </a:p>
         </p:txBody>
@@ -3708,7 +3712,7 @@
               </a:defRPr>
             </a:pPr>
             <a:r>
-              <a:t>Public logs + synthetic coverage for missing labels and scenarios</a:t>
+              <a:t>Attack traces are already in logs, but they are noisy and spread across systems.</a:t>
             </a:r>
           </a:p>
         </p:txBody>
@@ -3732,7 +3736,7 @@
           </a:solidFill>
           <a:ln w="19050">
             <a:solidFill>
-              <a:srgbClr val="3D8E6D"/>
+              <a:srgbClr val="2A6F97"/>
             </a:solidFill>
           </a:ln>
         </p:spPr>
@@ -3783,12 +3787,12 @@
             <a:pPr>
               <a:defRPr b="1" sz="1400">
                 <a:solidFill>
-                  <a:srgbClr val="3D8E6D"/>
-                </a:solidFill>
-              </a:defRPr>
-            </a:pPr>
-            <a:r>
-              <a:t>Model</a:t>
+                  <a:srgbClr val="2A6F97"/>
+                </a:solidFill>
+              </a:defRPr>
+            </a:pPr>
+            <a:r>
+              <a:t>How</a:t>
             </a:r>
           </a:p>
         </p:txBody>
@@ -3823,7 +3827,7 @@
               </a:defRPr>
             </a:pPr>
             <a:r>
-              <a:t>Unified binary detector plus SSH/web/firewall category specialists</a:t>
+              <a:t>ELK organizes events; ML prioritizes and categorizes suspicious activity.</a:t>
             </a:r>
           </a:p>
         </p:txBody>
@@ -3847,7 +3851,7 @@
           </a:solidFill>
           <a:ln w="19050">
             <a:solidFill>
-              <a:srgbClr val="E7A646"/>
+              <a:srgbClr val="3D8E6D"/>
             </a:solidFill>
           </a:ln>
         </p:spPr>
@@ -3898,12 +3902,12 @@
             <a:pPr>
               <a:defRPr b="1" sz="1400">
                 <a:solidFill>
-                  <a:srgbClr val="E7A646"/>
-                </a:solidFill>
-              </a:defRPr>
-            </a:pPr>
-            <a:r>
-              <a:t>Demo</a:t>
+                  <a:srgbClr val="3D8E6D"/>
+                </a:solidFill>
+              </a:defRPr>
+            </a:pPr>
+            <a:r>
+              <a:t>Outcome</a:t>
             </a:r>
           </a:p>
         </p:txBody>
@@ -3938,7 +3942,7 @@
               </a:defRPr>
             </a:pPr>
             <a:r>
-              <a:t>Scenario batch plus Podman ELK ingestion with Kibana</a:t>
+              <a:t>Analysts get searchable evidence plus model predictions in Kibana.</a:t>
             </a:r>
           </a:p>
         </p:txBody>
@@ -3991,7 +3995,7 @@
               </a:defRPr>
             </a:pPr>
             <a:r>
-              <a:t>ELK With Podman</a:t>
+              <a:t>Results</a:t>
             </a:r>
           </a:p>
         </p:txBody>
@@ -4074,16 +4078,300 @@
           </a:p>
         </p:txBody>
       </p:sp>
-      <p:sp>
-        <p:nvSpPr>
-          <p:cNvPr id="5" name="TextBox 4"/>
+      <p:graphicFrame>
+        <p:nvGraphicFramePr>
+          <p:cNvPr id="5" name="Chart 4"/>
+          <p:cNvGraphicFramePr>
+            <a:graphicFrameLocks noGrp="1"/>
+          </p:cNvGraphicFramePr>
+          <p:nvPr/>
+        </p:nvGraphicFramePr>
+        <p:xfrm>
+          <a:off x="777240" y="1143000"/>
+          <a:ext cx="5715000" cy="4114800"/>
+        </p:xfrm>
+        <a:graphic>
+          <a:graphicData uri="http://schemas.openxmlformats.org/drawingml/2006/chart">
+            <c:chart xmlns:c="http://schemas.openxmlformats.org/drawingml/2006/chart" r:id="rId2"/>
+          </a:graphicData>
+        </a:graphic>
+      </p:graphicFrame>
+      <p:graphicFrame>
+        <p:nvGraphicFramePr>
+          <p:cNvPr id="6" name="Table 5"/>
+          <p:cNvGraphicFramePr>
+            <a:graphicFrameLocks noGrp="1"/>
+          </p:cNvGraphicFramePr>
+          <p:nvPr/>
+        </p:nvGraphicFramePr>
+        <p:xfrm>
+          <a:off x="6720840" y="1325880"/>
+          <a:ext cx="4846320" cy="2514600"/>
+        </p:xfrm>
+        <a:graphic>
+          <a:graphicData uri="http://schemas.openxmlformats.org/drawingml/2006/table">
+            <a:tbl>
+              <a:tblPr firstRow="1" bandRow="1">
+                <a:tableStyleId>{5C22544A-7EE6-4342-B048-85BDC9FD1C3A}</a:tableStyleId>
+              </a:tblPr>
+              <a:tblGrid>
+                <a:gridCol w="2423160"/>
+                <a:gridCol w="2423160"/>
+              </a:tblGrid>
+              <a:tr h="502920">
+                <a:tc>
+                  <a:txBody>
+                    <a:bodyPr/>
+                    <a:lstStyle/>
+                    <a:p>
+                      <a:pPr>
+                        <a:defRPr b="1" sz="1000">
+                          <a:solidFill>
+                            <a:srgbClr val="FFFFFF"/>
+                          </a:solidFill>
+                        </a:defRPr>
+                      </a:pPr>
+                      <a:r>
+                        <a:t>Decision</a:t>
+                      </a:r>
+                    </a:p>
+                  </a:txBody>
+                  <a:tcPr>
+                    <a:solidFill>
+                      <a:srgbClr val="2A6F97"/>
+                    </a:solidFill>
+                  </a:tcPr>
+                </a:tc>
+                <a:tc>
+                  <a:txBody>
+                    <a:bodyPr/>
+                    <a:lstStyle/>
+                    <a:p>
+                      <a:pPr>
+                        <a:defRPr b="1" sz="1000">
+                          <a:solidFill>
+                            <a:srgbClr val="FFFFFF"/>
+                          </a:solidFill>
+                        </a:defRPr>
+                      </a:pPr>
+                      <a:r>
+                        <a:t>Evidence</a:t>
+                      </a:r>
+                    </a:p>
+                  </a:txBody>
+                  <a:tcPr>
+                    <a:solidFill>
+                      <a:srgbClr val="2A6F97"/>
+                    </a:solidFill>
+                  </a:tcPr>
+                </a:tc>
+              </a:tr>
+              <a:tr h="502920">
+                <a:tc>
+                  <a:txBody>
+                    <a:bodyPr/>
+                    <a:lstStyle/>
+                    <a:p>
+                      <a:pPr>
+                        <a:defRPr sz="900">
+                          <a:solidFill>
+                            <a:srgbClr val="1C232B"/>
+                          </a:solidFill>
+                        </a:defRPr>
+                      </a:pPr>
+                      <a:r>
+                        <a:t>Binary</a:t>
+                      </a:r>
+                    </a:p>
+                  </a:txBody>
+                  <a:tcPr>
+                    <a:solidFill>
+                      <a:srgbClr val="FFFFFF"/>
+                    </a:solidFill>
+                  </a:tcPr>
+                </a:tc>
+                <a:tc>
+                  <a:txBody>
+                    <a:bodyPr/>
+                    <a:lstStyle/>
+                    <a:p>
+                      <a:pPr>
+                        <a:defRPr sz="900">
+                          <a:solidFill>
+                            <a:srgbClr val="1C232B"/>
+                          </a:solidFill>
+                        </a:defRPr>
+                      </a:pPr>
+                      <a:r>
+                        <a:t>Unified binary macro F1: 0.9929</a:t>
+                      </a:r>
+                    </a:p>
+                  </a:txBody>
+                  <a:tcPr>
+                    <a:solidFill>
+                      <a:srgbClr val="FFFFFF"/>
+                    </a:solidFill>
+                  </a:tcPr>
+                </a:tc>
+              </a:tr>
+              <a:tr h="502920">
+                <a:tc>
+                  <a:txBody>
+                    <a:bodyPr/>
+                    <a:lstStyle/>
+                    <a:p>
+                      <a:pPr>
+                        <a:defRPr sz="900">
+                          <a:solidFill>
+                            <a:srgbClr val="1C232B"/>
+                          </a:solidFill>
+                        </a:defRPr>
+                      </a:pPr>
+                      <a:r>
+                        <a:t>Category</a:t>
+                      </a:r>
+                    </a:p>
+                  </a:txBody>
+                  <a:tcPr>
+                    <a:solidFill>
+                      <a:srgbClr val="F7F9FA"/>
+                    </a:solidFill>
+                  </a:tcPr>
+                </a:tc>
+                <a:tc>
+                  <a:txBody>
+                    <a:bodyPr/>
+                    <a:lstStyle/>
+                    <a:p>
+                      <a:pPr>
+                        <a:defRPr sz="900">
+                          <a:solidFill>
+                            <a:srgbClr val="1C232B"/>
+                          </a:solidFill>
+                        </a:defRPr>
+                      </a:pPr>
+                      <a:r>
+                        <a:t>Unified category macro F1: 0.9447</a:t>
+                      </a:r>
+                    </a:p>
+                  </a:txBody>
+                  <a:tcPr>
+                    <a:solidFill>
+                      <a:srgbClr val="F7F9FA"/>
+                    </a:solidFill>
+                  </a:tcPr>
+                </a:tc>
+              </a:tr>
+              <a:tr h="502920">
+                <a:tc>
+                  <a:txBody>
+                    <a:bodyPr/>
+                    <a:lstStyle/>
+                    <a:p>
+                      <a:pPr>
+                        <a:defRPr sz="900">
+                          <a:solidFill>
+                            <a:srgbClr val="1C232B"/>
+                          </a:solidFill>
+                        </a:defRPr>
+                      </a:pPr>
+                      <a:r>
+                        <a:t>Specialists</a:t>
+                      </a:r>
+                    </a:p>
+                  </a:txBody>
+                  <a:tcPr>
+                    <a:solidFill>
+                      <a:srgbClr val="FFFFFF"/>
+                    </a:solidFill>
+                  </a:tcPr>
+                </a:tc>
+                <a:tc>
+                  <a:txBody>
+                    <a:bodyPr/>
+                    <a:lstStyle/>
+                    <a:p>
+                      <a:pPr>
+                        <a:defRPr sz="900">
+                          <a:solidFill>
+                            <a:srgbClr val="1C232B"/>
+                          </a:solidFill>
+                        </a:defRPr>
+                      </a:pPr>
+                      <a:r>
+                        <a:t>Web and firewall category specialists improved diagnosis</a:t>
+                      </a:r>
+                    </a:p>
+                  </a:txBody>
+                  <a:tcPr>
+                    <a:solidFill>
+                      <a:srgbClr val="FFFFFF"/>
+                    </a:solidFill>
+                  </a:tcPr>
+                </a:tc>
+              </a:tr>
+              <a:tr h="502920">
+                <a:tc>
+                  <a:txBody>
+                    <a:bodyPr/>
+                    <a:lstStyle/>
+                    <a:p>
+                      <a:pPr>
+                        <a:defRPr sz="900">
+                          <a:solidFill>
+                            <a:srgbClr val="1C232B"/>
+                          </a:solidFill>
+                        </a:defRPr>
+                      </a:pPr>
+                      <a:r>
+                        <a:t>Final</a:t>
+                      </a:r>
+                    </a:p>
+                  </a:txBody>
+                  <a:tcPr>
+                    <a:solidFill>
+                      <a:srgbClr val="F7F9FA"/>
+                    </a:solidFill>
+                  </a:tcPr>
+                </a:tc>
+                <a:tc>
+                  <a:txBody>
+                    <a:bodyPr/>
+                    <a:lstStyle/>
+                    <a:p>
+                      <a:pPr>
+                        <a:defRPr sz="900">
+                          <a:solidFill>
+                            <a:srgbClr val="1C232B"/>
+                          </a:solidFill>
+                        </a:defRPr>
+                      </a:pPr>
+                      <a:r>
+                        <a:t>Unified binary + specialist categories</a:t>
+                      </a:r>
+                    </a:p>
+                  </a:txBody>
+                  <a:tcPr>
+                    <a:solidFill>
+                      <a:srgbClr val="F7F9FA"/>
+                    </a:solidFill>
+                  </a:tcPr>
+                </a:tc>
+              </a:tr>
+            </a:tbl>
+          </a:graphicData>
+        </a:graphic>
+      </p:graphicFrame>
+      <p:sp>
+        <p:nvSpPr>
+          <p:cNvPr id="7" name="TextBox 6"/>
           <p:cNvSpPr txBox="1"/>
           <p:nvPr/>
         </p:nvSpPr>
         <p:spPr>
           <a:xfrm>
-            <a:off x="822960" y="1234440"/>
-            <a:ext cx="10789920" cy="4023360"/>
+            <a:off x="6812280" y="4160520"/>
+            <a:ext cx="4572000" cy="731520"/>
           </a:xfrm>
           <a:prstGeom prst="rect">
             <a:avLst/>
@@ -4100,74 +4388,14 @@
               <a:spcAft>
                 <a:spcPts val="800"/>
               </a:spcAft>
-              <a:defRPr sz="1800">
+              <a:defRPr sz="1600">
                 <a:solidFill>
                   <a:srgbClr val="1C232B"/>
                 </a:solidFill>
               </a:defRPr>
             </a:pPr>
             <a:r>
-              <a:t>Logstash parses sample SSH, web, and firewall logs.</a:t>
-            </a:r>
-          </a:p>
-          <a:p>
-            <a:pPr>
-              <a:spcAft>
-                <a:spcPts val="800"/>
-              </a:spcAft>
-              <a:defRPr sz="1800">
-                <a:solidFill>
-                  <a:srgbClr val="1C232B"/>
-                </a:solidFill>
-              </a:defRPr>
-            </a:pPr>
-            <a:r>
-              <a:t>Elasticsearch stores normalized events.</a:t>
-            </a:r>
-          </a:p>
-          <a:p>
-            <a:pPr>
-              <a:spcAft>
-                <a:spcPts val="800"/>
-              </a:spcAft>
-              <a:defRPr sz="1800">
-                <a:solidFill>
-                  <a:srgbClr val="1C232B"/>
-                </a:solidFill>
-              </a:defRPr>
-            </a:pPr>
-            <a:r>
-              <a:t>Kibana supports analyst inspection and dashboards.</a:t>
-            </a:r>
-          </a:p>
-          <a:p>
-            <a:pPr>
-              <a:spcAft>
-                <a:spcPts val="800"/>
-              </a:spcAft>
-              <a:defRPr sz="1800">
-                <a:solidFill>
-                  <a:srgbClr val="1C232B"/>
-                </a:solidFill>
-              </a:defRPr>
-            </a:pPr>
-            <a:r>
-              <a:t>Podman starts the local stack with: podman-compose -f compose.yaml up -d</a:t>
-            </a:r>
-          </a:p>
-          <a:p>
-            <a:pPr>
-              <a:spcAft>
-                <a:spcPts val="800"/>
-              </a:spcAft>
-              <a:defRPr sz="1800">
-                <a:solidFill>
-                  <a:srgbClr val="1C232B"/>
-                </a:solidFill>
-              </a:defRPr>
-            </a:pPr>
-            <a:r>
-              <a:t>ELK is ingestion/exploration; ML scoring is a separate pipeline.</a:t>
+              <a:t>Metrics prove pipeline behavior on current data, not production readiness.</a:t>
             </a:r>
           </a:p>
         </p:txBody>
@@ -4220,7 +4448,7 @@
               </a:defRPr>
             </a:pPr>
             <a:r>
-              <a:t>Limitations</a:t>
+              <a:t>Scenario Demo</a:t>
             </a:r>
           </a:p>
         </p:txBody>
@@ -4299,6 +4527,2278 @@
             </a:pPr>
             <a:r>
               <a:t>Cyber Log Attack Detection | 11</a:t>
+            </a:r>
+          </a:p>
+        </p:txBody>
+      </p:sp>
+      <p:graphicFrame>
+        <p:nvGraphicFramePr>
+          <p:cNvPr id="5" name="Table 4"/>
+          <p:cNvGraphicFramePr>
+            <a:graphicFrameLocks noGrp="1"/>
+          </p:cNvGraphicFramePr>
+          <p:nvPr/>
+        </p:nvGraphicFramePr>
+        <p:xfrm>
+          <a:off x="822960" y="1234440"/>
+          <a:ext cx="4754880" cy="2331720"/>
+        </p:xfrm>
+        <a:graphic>
+          <a:graphicData uri="http://schemas.openxmlformats.org/drawingml/2006/table">
+            <a:tbl>
+              <a:tblPr firstRow="1" bandRow="1">
+                <a:tableStyleId>{5C22544A-7EE6-4342-B048-85BDC9FD1C3A}</a:tableStyleId>
+              </a:tblPr>
+              <a:tblGrid>
+                <a:gridCol w="2377440"/>
+                <a:gridCol w="2377440"/>
+              </a:tblGrid>
+              <a:tr h="388620">
+                <a:tc>
+                  <a:txBody>
+                    <a:bodyPr/>
+                    <a:lstStyle/>
+                    <a:p>
+                      <a:pPr>
+                        <a:defRPr b="1" sz="1000">
+                          <a:solidFill>
+                            <a:srgbClr val="FFFFFF"/>
+                          </a:solidFill>
+                        </a:defRPr>
+                      </a:pPr>
+                      <a:r>
+                        <a:t>Metric</a:t>
+                      </a:r>
+                    </a:p>
+                  </a:txBody>
+                  <a:tcPr>
+                    <a:solidFill>
+                      <a:srgbClr val="2A6F97"/>
+                    </a:solidFill>
+                  </a:tcPr>
+                </a:tc>
+                <a:tc>
+                  <a:txBody>
+                    <a:bodyPr/>
+                    <a:lstStyle/>
+                    <a:p>
+                      <a:pPr>
+                        <a:defRPr b="1" sz="1000">
+                          <a:solidFill>
+                            <a:srgbClr val="FFFFFF"/>
+                          </a:solidFill>
+                        </a:defRPr>
+                      </a:pPr>
+                      <a:r>
+                        <a:t>Value</a:t>
+                      </a:r>
+                    </a:p>
+                  </a:txBody>
+                  <a:tcPr>
+                    <a:solidFill>
+                      <a:srgbClr val="2A6F97"/>
+                    </a:solidFill>
+                  </a:tcPr>
+                </a:tc>
+              </a:tr>
+              <a:tr h="388620">
+                <a:tc>
+                  <a:txBody>
+                    <a:bodyPr/>
+                    <a:lstStyle/>
+                    <a:p>
+                      <a:pPr>
+                        <a:defRPr sz="900">
+                          <a:solidFill>
+                            <a:srgbClr val="1C232B"/>
+                          </a:solidFill>
+                        </a:defRPr>
+                      </a:pPr>
+                      <a:r>
+                        <a:t>Rows scored</a:t>
+                      </a:r>
+                    </a:p>
+                  </a:txBody>
+                  <a:tcPr>
+                    <a:solidFill>
+                      <a:srgbClr val="FFFFFF"/>
+                    </a:solidFill>
+                  </a:tcPr>
+                </a:tc>
+                <a:tc>
+                  <a:txBody>
+                    <a:bodyPr/>
+                    <a:lstStyle/>
+                    <a:p>
+                      <a:pPr>
+                        <a:defRPr sz="900">
+                          <a:solidFill>
+                            <a:srgbClr val="1C232B"/>
+                          </a:solidFill>
+                        </a:defRPr>
+                      </a:pPr>
+                      <a:r>
+                        <a:t>18</a:t>
+                      </a:r>
+                    </a:p>
+                  </a:txBody>
+                  <a:tcPr>
+                    <a:solidFill>
+                      <a:srgbClr val="FFFFFF"/>
+                    </a:solidFill>
+                  </a:tcPr>
+                </a:tc>
+              </a:tr>
+              <a:tr h="388620">
+                <a:tc>
+                  <a:txBody>
+                    <a:bodyPr/>
+                    <a:lstStyle/>
+                    <a:p>
+                      <a:pPr>
+                        <a:defRPr sz="900">
+                          <a:solidFill>
+                            <a:srgbClr val="1C232B"/>
+                          </a:solidFill>
+                        </a:defRPr>
+                      </a:pPr>
+                      <a:r>
+                        <a:t>Expected attacks</a:t>
+                      </a:r>
+                    </a:p>
+                  </a:txBody>
+                  <a:tcPr>
+                    <a:solidFill>
+                      <a:srgbClr val="F7F9FA"/>
+                    </a:solidFill>
+                  </a:tcPr>
+                </a:tc>
+                <a:tc>
+                  <a:txBody>
+                    <a:bodyPr/>
+                    <a:lstStyle/>
+                    <a:p>
+                      <a:pPr>
+                        <a:defRPr sz="900">
+                          <a:solidFill>
+                            <a:srgbClr val="1C232B"/>
+                          </a:solidFill>
+                        </a:defRPr>
+                      </a:pPr>
+                      <a:r>
+                        <a:t>12</a:t>
+                      </a:r>
+                    </a:p>
+                  </a:txBody>
+                  <a:tcPr>
+                    <a:solidFill>
+                      <a:srgbClr val="F7F9FA"/>
+                    </a:solidFill>
+                  </a:tcPr>
+                </a:tc>
+              </a:tr>
+              <a:tr h="388620">
+                <a:tc>
+                  <a:txBody>
+                    <a:bodyPr/>
+                    <a:lstStyle/>
+                    <a:p>
+                      <a:pPr>
+                        <a:defRPr sz="900">
+                          <a:solidFill>
+                            <a:srgbClr val="1C232B"/>
+                          </a:solidFill>
+                        </a:defRPr>
+                      </a:pPr>
+                      <a:r>
+                        <a:t>Predicted attacks</a:t>
+                      </a:r>
+                    </a:p>
+                  </a:txBody>
+                  <a:tcPr>
+                    <a:solidFill>
+                      <a:srgbClr val="FFFFFF"/>
+                    </a:solidFill>
+                  </a:tcPr>
+                </a:tc>
+                <a:tc>
+                  <a:txBody>
+                    <a:bodyPr/>
+                    <a:lstStyle/>
+                    <a:p>
+                      <a:pPr>
+                        <a:defRPr sz="900">
+                          <a:solidFill>
+                            <a:srgbClr val="1C232B"/>
+                          </a:solidFill>
+                        </a:defRPr>
+                      </a:pPr>
+                      <a:r>
+                        <a:t>11</a:t>
+                      </a:r>
+                    </a:p>
+                  </a:txBody>
+                  <a:tcPr>
+                    <a:solidFill>
+                      <a:srgbClr val="FFFFFF"/>
+                    </a:solidFill>
+                  </a:tcPr>
+                </a:tc>
+              </a:tr>
+              <a:tr h="388620">
+                <a:tc>
+                  <a:txBody>
+                    <a:bodyPr/>
+                    <a:lstStyle/>
+                    <a:p>
+                      <a:pPr>
+                        <a:defRPr sz="900">
+                          <a:solidFill>
+                            <a:srgbClr val="1C232B"/>
+                          </a:solidFill>
+                        </a:defRPr>
+                      </a:pPr>
+                      <a:r>
+                        <a:t>Binary accuracy</a:t>
+                      </a:r>
+                    </a:p>
+                  </a:txBody>
+                  <a:tcPr>
+                    <a:solidFill>
+                      <a:srgbClr val="F7F9FA"/>
+                    </a:solidFill>
+                  </a:tcPr>
+                </a:tc>
+                <a:tc>
+                  <a:txBody>
+                    <a:bodyPr/>
+                    <a:lstStyle/>
+                    <a:p>
+                      <a:pPr>
+                        <a:defRPr sz="900">
+                          <a:solidFill>
+                            <a:srgbClr val="1C232B"/>
+                          </a:solidFill>
+                        </a:defRPr>
+                      </a:pPr>
+                      <a:r>
+                        <a:t>0.944</a:t>
+                      </a:r>
+                    </a:p>
+                  </a:txBody>
+                  <a:tcPr>
+                    <a:solidFill>
+                      <a:srgbClr val="F7F9FA"/>
+                    </a:solidFill>
+                  </a:tcPr>
+                </a:tc>
+              </a:tr>
+              <a:tr h="388620">
+                <a:tc>
+                  <a:txBody>
+                    <a:bodyPr/>
+                    <a:lstStyle/>
+                    <a:p>
+                      <a:pPr>
+                        <a:defRPr sz="900">
+                          <a:solidFill>
+                            <a:srgbClr val="1C232B"/>
+                          </a:solidFill>
+                        </a:defRPr>
+                      </a:pPr>
+                      <a:r>
+                        <a:t>Category accuracy on attacks</a:t>
+                      </a:r>
+                    </a:p>
+                  </a:txBody>
+                  <a:tcPr>
+                    <a:solidFill>
+                      <a:srgbClr val="FFFFFF"/>
+                    </a:solidFill>
+                  </a:tcPr>
+                </a:tc>
+                <a:tc>
+                  <a:txBody>
+                    <a:bodyPr/>
+                    <a:lstStyle/>
+                    <a:p>
+                      <a:pPr>
+                        <a:defRPr sz="900">
+                          <a:solidFill>
+                            <a:srgbClr val="1C232B"/>
+                          </a:solidFill>
+                        </a:defRPr>
+                      </a:pPr>
+                      <a:r>
+                        <a:t>0.833</a:t>
+                      </a:r>
+                    </a:p>
+                  </a:txBody>
+                  <a:tcPr>
+                    <a:solidFill>
+                      <a:srgbClr val="FFFFFF"/>
+                    </a:solidFill>
+                  </a:tcPr>
+                </a:tc>
+              </a:tr>
+            </a:tbl>
+          </a:graphicData>
+        </a:graphic>
+      </p:graphicFrame>
+      <p:sp>
+        <p:nvSpPr>
+          <p:cNvPr id="6" name="TextBox 5"/>
+          <p:cNvSpPr txBox="1"/>
+          <p:nvPr/>
+        </p:nvSpPr>
+        <p:spPr>
+          <a:xfrm>
+            <a:off x="6126480" y="1325880"/>
+            <a:ext cx="5303520" cy="2423160"/>
+          </a:xfrm>
+          <a:prstGeom prst="rect">
+            <a:avLst/>
+          </a:prstGeom>
+          <a:noFill/>
+        </p:spPr>
+        <p:txBody>
+          <a:bodyPr wrap="none">
+            <a:spAutoFit/>
+          </a:bodyPr>
+          <a:lstStyle/>
+          <a:p>
+            <a:pPr>
+              <a:spcAft>
+                <a:spcPts val="800"/>
+              </a:spcAft>
+              <a:defRPr sz="1700">
+                <a:solidFill>
+                  <a:srgbClr val="1C232B"/>
+                </a:solidFill>
+              </a:defRPr>
+            </a:pPr>
+            <a:r>
+              <a:t>One SQL injection was categorized as XSS.</a:t>
+            </a:r>
+          </a:p>
+          <a:p>
+            <a:pPr>
+              <a:spcAft>
+                <a:spcPts val="800"/>
+              </a:spcAft>
+              <a:defRPr sz="1700">
+                <a:solidFill>
+                  <a:srgbClr val="1C232B"/>
+                </a:solidFill>
+              </a:defRPr>
+            </a:pPr>
+            <a:r>
+              <a:t>One suspicious outbound firewall event was missed by the binary gate.</a:t>
+            </a:r>
+          </a:p>
+          <a:p>
+            <a:pPr>
+              <a:spcAft>
+                <a:spcPts val="800"/>
+              </a:spcAft>
+              <a:defRPr sz="1700">
+                <a:solidFill>
+                  <a:srgbClr val="1C232B"/>
+                </a:solidFill>
+              </a:defRPr>
+            </a:pPr>
+            <a:r>
+              <a:t>These visible mistakes are useful: they show where more real data and better windows are needed.</a:t>
+            </a:r>
+          </a:p>
+        </p:txBody>
+      </p:sp>
+    </p:spTree>
+  </p:cSld>
+  <p:clrMapOvr>
+    <a:masterClrMapping/>
+  </p:clrMapOvr>
+</p:sld>
+</file>
+
+<file path=ppt/slides/slide12.xml><?xml version="1.0" encoding="utf-8"?>
+<p:sld xmlns:a="http://schemas.openxmlformats.org/drawingml/2006/main" xmlns:p="http://schemas.openxmlformats.org/presentationml/2006/main" xmlns:r="http://schemas.openxmlformats.org/officeDocument/2006/relationships">
+  <p:cSld>
+    <p:spTree>
+      <p:nvGrpSpPr>
+        <p:cNvPr id="1" name=""/>
+        <p:cNvGrpSpPr/>
+        <p:nvPr/>
+      </p:nvGrpSpPr>
+      <p:grpSpPr/>
+      <p:sp>
+        <p:nvSpPr>
+          <p:cNvPr id="2" name="TextBox 1"/>
+          <p:cNvSpPr txBox="1"/>
+          <p:nvPr/>
+        </p:nvSpPr>
+        <p:spPr>
+          <a:xfrm>
+            <a:off x="502920" y="320040"/>
+            <a:ext cx="11155680" cy="548640"/>
+          </a:xfrm>
+          <a:prstGeom prst="rect">
+            <a:avLst/>
+          </a:prstGeom>
+          <a:noFill/>
+        </p:spPr>
+        <p:txBody>
+          <a:bodyPr wrap="none">
+            <a:spAutoFit/>
+          </a:bodyPr>
+          <a:lstStyle/>
+          <a:p>
+            <a:pPr>
+              <a:defRPr sz="2800" b="1">
+                <a:solidFill>
+                  <a:srgbClr val="1C232B"/>
+                </a:solidFill>
+              </a:defRPr>
+            </a:pPr>
+            <a:r>
+              <a:t>ELK With Podman</a:t>
+            </a:r>
+          </a:p>
+        </p:txBody>
+      </p:sp>
+      <p:sp>
+        <p:nvSpPr>
+          <p:cNvPr id="3" name="Rectangle 2"/>
+          <p:cNvSpPr/>
+          <p:nvPr/>
+        </p:nvSpPr>
+        <p:spPr>
+          <a:xfrm>
+            <a:off x="0" y="6556248"/>
+            <a:ext cx="12188952" cy="36576"/>
+          </a:xfrm>
+          <a:prstGeom prst="rect">
+            <a:avLst/>
+          </a:prstGeom>
+          <a:solidFill>
+            <a:srgbClr val="D2D8DE"/>
+          </a:solidFill>
+          <a:ln>
+            <a:noFill/>
+          </a:ln>
+        </p:spPr>
+        <p:style>
+          <a:lnRef idx="1">
+            <a:schemeClr val="accent1"/>
+          </a:lnRef>
+          <a:fillRef idx="3">
+            <a:schemeClr val="accent1"/>
+          </a:fillRef>
+          <a:effectRef idx="2">
+            <a:schemeClr val="accent1"/>
+          </a:effectRef>
+          <a:fontRef idx="minor">
+            <a:schemeClr val="lt1"/>
+          </a:fontRef>
+        </p:style>
+        <p:txBody>
+          <a:bodyPr rtlCol="0" anchor="ctr"/>
+          <a:lstStyle/>
+          <a:p>
+            <a:pPr algn="ctr"/>
+          </a:p>
+        </p:txBody>
+      </p:sp>
+      <p:sp>
+        <p:nvSpPr>
+          <p:cNvPr id="4" name="TextBox 3"/>
+          <p:cNvSpPr txBox="1"/>
+          <p:nvPr/>
+        </p:nvSpPr>
+        <p:spPr>
+          <a:xfrm>
+            <a:off x="502920" y="6601968"/>
+            <a:ext cx="11155680" cy="228600"/>
+          </a:xfrm>
+          <a:prstGeom prst="rect">
+            <a:avLst/>
+          </a:prstGeom>
+          <a:noFill/>
+        </p:spPr>
+        <p:txBody>
+          <a:bodyPr wrap="none">
+            <a:spAutoFit/>
+          </a:bodyPr>
+          <a:lstStyle/>
+          <a:p>
+            <a:pPr>
+              <a:defRPr sz="800">
+                <a:solidFill>
+                  <a:srgbClr val="586370"/>
+                </a:solidFill>
+              </a:defRPr>
+            </a:pPr>
+            <a:r>
+              <a:t>Cyber Log Attack Detection | 12</a:t>
+            </a:r>
+          </a:p>
+        </p:txBody>
+      </p:sp>
+      <p:sp>
+        <p:nvSpPr>
+          <p:cNvPr id="5" name="TextBox 4"/>
+          <p:cNvSpPr txBox="1"/>
+          <p:nvPr/>
+        </p:nvSpPr>
+        <p:spPr>
+          <a:xfrm>
+            <a:off x="822960" y="1234440"/>
+            <a:ext cx="10789920" cy="4023360"/>
+          </a:xfrm>
+          <a:prstGeom prst="rect">
+            <a:avLst/>
+          </a:prstGeom>
+          <a:noFill/>
+        </p:spPr>
+        <p:txBody>
+          <a:bodyPr wrap="none">
+            <a:spAutoFit/>
+          </a:bodyPr>
+          <a:lstStyle/>
+          <a:p>
+            <a:pPr>
+              <a:spcAft>
+                <a:spcPts val="800"/>
+              </a:spcAft>
+              <a:defRPr sz="1800">
+                <a:solidFill>
+                  <a:srgbClr val="1C232B"/>
+                </a:solidFill>
+              </a:defRPr>
+            </a:pPr>
+            <a:r>
+              <a:t>Logstash parses sample SSH, web, and firewall logs into structured fields.</a:t>
+            </a:r>
+          </a:p>
+          <a:p>
+            <a:pPr>
+              <a:spcAft>
+                <a:spcPts val="800"/>
+              </a:spcAft>
+              <a:defRPr sz="1800">
+                <a:solidFill>
+                  <a:srgbClr val="1C232B"/>
+                </a:solidFill>
+              </a:defRPr>
+            </a:pPr>
+            <a:r>
+              <a:t>Elasticsearch stores those events in cyberlog-events-* indexes.</a:t>
+            </a:r>
+          </a:p>
+          <a:p>
+            <a:pPr>
+              <a:spcAft>
+                <a:spcPts val="800"/>
+              </a:spcAft>
+              <a:defRPr sz="1800">
+                <a:solidFill>
+                  <a:srgbClr val="1C232B"/>
+                </a:solidFill>
+              </a:defRPr>
+            </a:pPr>
+            <a:r>
+              <a:t>Kibana gives the analyst a searchable view of raw and parsed evidence.</a:t>
+            </a:r>
+          </a:p>
+          <a:p>
+            <a:pPr>
+              <a:spcAft>
+                <a:spcPts val="800"/>
+              </a:spcAft>
+              <a:defRPr sz="1800">
+                <a:solidFill>
+                  <a:srgbClr val="1C232B"/>
+                </a:solidFill>
+              </a:defRPr>
+            </a:pPr>
+            <a:r>
+              <a:t>Podman starts the local stack with: podman-compose -f compose.yaml up -d</a:t>
+            </a:r>
+          </a:p>
+          <a:p>
+            <a:pPr>
+              <a:spcAft>
+                <a:spcPts val="800"/>
+              </a:spcAft>
+              <a:defRPr sz="1800">
+                <a:solidFill>
+                  <a:srgbClr val="1C232B"/>
+                </a:solidFill>
+              </a:defRPr>
+            </a:pPr>
+            <a:r>
+              <a:t>The ML bridge then reads those events, scores them, and writes predictions back.</a:t>
+            </a:r>
+          </a:p>
+        </p:txBody>
+      </p:sp>
+    </p:spTree>
+  </p:cSld>
+  <p:clrMapOvr>
+    <a:masterClrMapping/>
+  </p:clrMapOvr>
+</p:sld>
+</file>
+
+<file path=ppt/slides/slide13.xml><?xml version="1.0" encoding="utf-8"?>
+<p:sld xmlns:a="http://schemas.openxmlformats.org/drawingml/2006/main" xmlns:p="http://schemas.openxmlformats.org/presentationml/2006/main" xmlns:r="http://schemas.openxmlformats.org/officeDocument/2006/relationships">
+  <p:cSld>
+    <p:spTree>
+      <p:nvGrpSpPr>
+        <p:cNvPr id="1" name=""/>
+        <p:cNvGrpSpPr/>
+        <p:nvPr/>
+      </p:nvGrpSpPr>
+      <p:grpSpPr/>
+      <p:sp>
+        <p:nvSpPr>
+          <p:cNvPr id="2" name="TextBox 1"/>
+          <p:cNvSpPr txBox="1"/>
+          <p:nvPr/>
+        </p:nvSpPr>
+        <p:spPr>
+          <a:xfrm>
+            <a:off x="502920" y="320040"/>
+            <a:ext cx="11155680" cy="548640"/>
+          </a:xfrm>
+          <a:prstGeom prst="rect">
+            <a:avLst/>
+          </a:prstGeom>
+          <a:noFill/>
+        </p:spPr>
+        <p:txBody>
+          <a:bodyPr wrap="none">
+            <a:spAutoFit/>
+          </a:bodyPr>
+          <a:lstStyle/>
+          <a:p>
+            <a:pPr>
+              <a:defRPr sz="2800" b="1">
+                <a:solidFill>
+                  <a:srgbClr val="1C232B"/>
+                </a:solidFill>
+              </a:defRPr>
+            </a:pPr>
+            <a:r>
+              <a:t>ELK To ML Scoring Loop</a:t>
+            </a:r>
+          </a:p>
+        </p:txBody>
+      </p:sp>
+      <p:sp>
+        <p:nvSpPr>
+          <p:cNvPr id="3" name="Rectangle 2"/>
+          <p:cNvSpPr/>
+          <p:nvPr/>
+        </p:nvSpPr>
+        <p:spPr>
+          <a:xfrm>
+            <a:off x="0" y="6556248"/>
+            <a:ext cx="12188952" cy="36576"/>
+          </a:xfrm>
+          <a:prstGeom prst="rect">
+            <a:avLst/>
+          </a:prstGeom>
+          <a:solidFill>
+            <a:srgbClr val="D2D8DE"/>
+          </a:solidFill>
+          <a:ln>
+            <a:noFill/>
+          </a:ln>
+        </p:spPr>
+        <p:style>
+          <a:lnRef idx="1">
+            <a:schemeClr val="accent1"/>
+          </a:lnRef>
+          <a:fillRef idx="3">
+            <a:schemeClr val="accent1"/>
+          </a:fillRef>
+          <a:effectRef idx="2">
+            <a:schemeClr val="accent1"/>
+          </a:effectRef>
+          <a:fontRef idx="minor">
+            <a:schemeClr val="lt1"/>
+          </a:fontRef>
+        </p:style>
+        <p:txBody>
+          <a:bodyPr rtlCol="0" anchor="ctr"/>
+          <a:lstStyle/>
+          <a:p>
+            <a:pPr algn="ctr"/>
+          </a:p>
+        </p:txBody>
+      </p:sp>
+      <p:sp>
+        <p:nvSpPr>
+          <p:cNvPr id="4" name="TextBox 3"/>
+          <p:cNvSpPr txBox="1"/>
+          <p:nvPr/>
+        </p:nvSpPr>
+        <p:spPr>
+          <a:xfrm>
+            <a:off x="502920" y="6601968"/>
+            <a:ext cx="11155680" cy="228600"/>
+          </a:xfrm>
+          <a:prstGeom prst="rect">
+            <a:avLst/>
+          </a:prstGeom>
+          <a:noFill/>
+        </p:spPr>
+        <p:txBody>
+          <a:bodyPr wrap="none">
+            <a:spAutoFit/>
+          </a:bodyPr>
+          <a:lstStyle/>
+          <a:p>
+            <a:pPr>
+              <a:defRPr sz="800">
+                <a:solidFill>
+                  <a:srgbClr val="586370"/>
+                </a:solidFill>
+              </a:defRPr>
+            </a:pPr>
+            <a:r>
+              <a:t>Cyber Log Attack Detection | 13</a:t>
+            </a:r>
+          </a:p>
+        </p:txBody>
+      </p:sp>
+      <p:sp>
+        <p:nvSpPr>
+          <p:cNvPr id="5" name="Rounded Rectangle 4"/>
+          <p:cNvSpPr/>
+          <p:nvPr/>
+        </p:nvSpPr>
+        <p:spPr>
+          <a:xfrm>
+            <a:off x="594360" y="1188720"/>
+            <a:ext cx="2057400" cy="1143000"/>
+          </a:xfrm>
+          <a:prstGeom prst="roundRect">
+            <a:avLst/>
+          </a:prstGeom>
+          <a:solidFill>
+            <a:srgbClr val="F7F9FA"/>
+          </a:solidFill>
+          <a:ln w="19050">
+            <a:solidFill>
+              <a:srgbClr val="2A6F97"/>
+            </a:solidFill>
+          </a:ln>
+        </p:spPr>
+        <p:style>
+          <a:lnRef idx="1">
+            <a:schemeClr val="accent1"/>
+          </a:lnRef>
+          <a:fillRef idx="3">
+            <a:schemeClr val="accent1"/>
+          </a:fillRef>
+          <a:effectRef idx="2">
+            <a:schemeClr val="accent1"/>
+          </a:effectRef>
+          <a:fontRef idx="minor">
+            <a:schemeClr val="lt1"/>
+          </a:fontRef>
+        </p:style>
+        <p:txBody>
+          <a:bodyPr rtlCol="0" anchor="ctr"/>
+          <a:lstStyle/>
+          <a:p>
+            <a:pPr algn="ctr"/>
+          </a:p>
+        </p:txBody>
+      </p:sp>
+      <p:sp>
+        <p:nvSpPr>
+          <p:cNvPr id="6" name="TextBox 5"/>
+          <p:cNvSpPr txBox="1"/>
+          <p:nvPr/>
+        </p:nvSpPr>
+        <p:spPr>
+          <a:xfrm>
+            <a:off x="758952" y="1298448"/>
+            <a:ext cx="1728216" cy="256032"/>
+          </a:xfrm>
+          <a:prstGeom prst="rect">
+            <a:avLst/>
+          </a:prstGeom>
+          <a:noFill/>
+        </p:spPr>
+        <p:txBody>
+          <a:bodyPr wrap="none">
+            <a:spAutoFit/>
+          </a:bodyPr>
+          <a:lstStyle/>
+          <a:p>
+            <a:pPr>
+              <a:defRPr b="1" sz="1400">
+                <a:solidFill>
+                  <a:srgbClr val="2A6F97"/>
+                </a:solidFill>
+              </a:defRPr>
+            </a:pPr>
+            <a:r>
+              <a:t>1. Events</a:t>
+            </a:r>
+          </a:p>
+        </p:txBody>
+      </p:sp>
+      <p:sp>
+        <p:nvSpPr>
+          <p:cNvPr id="7" name="TextBox 6"/>
+          <p:cNvSpPr txBox="1"/>
+          <p:nvPr/>
+        </p:nvSpPr>
+        <p:spPr>
+          <a:xfrm>
+            <a:off x="758952" y="1627632"/>
+            <a:ext cx="1728216" cy="640080"/>
+          </a:xfrm>
+          <a:prstGeom prst="rect">
+            <a:avLst/>
+          </a:prstGeom>
+          <a:noFill/>
+        </p:spPr>
+        <p:txBody>
+          <a:bodyPr wrap="none">
+            <a:spAutoFit/>
+          </a:bodyPr>
+          <a:lstStyle/>
+          <a:p>
+            <a:pPr>
+              <a:defRPr sz="1100">
+                <a:solidFill>
+                  <a:srgbClr val="1C232B"/>
+                </a:solidFill>
+              </a:defRPr>
+            </a:pPr>
+            <a:r>
+              <a:t>Logstash writes parsed logs to cyberlog-events-*.</a:t>
+            </a:r>
+          </a:p>
+        </p:txBody>
+      </p:sp>
+      <p:sp>
+        <p:nvSpPr>
+          <p:cNvPr id="8" name="Rounded Rectangle 7"/>
+          <p:cNvSpPr/>
+          <p:nvPr/>
+        </p:nvSpPr>
+        <p:spPr>
+          <a:xfrm>
+            <a:off x="2788920" y="1188720"/>
+            <a:ext cx="2057400" cy="1143000"/>
+          </a:xfrm>
+          <a:prstGeom prst="roundRect">
+            <a:avLst/>
+          </a:prstGeom>
+          <a:solidFill>
+            <a:srgbClr val="F7F9FA"/>
+          </a:solidFill>
+          <a:ln w="19050">
+            <a:solidFill>
+              <a:srgbClr val="E7A646"/>
+            </a:solidFill>
+          </a:ln>
+        </p:spPr>
+        <p:style>
+          <a:lnRef idx="1">
+            <a:schemeClr val="accent1"/>
+          </a:lnRef>
+          <a:fillRef idx="3">
+            <a:schemeClr val="accent1"/>
+          </a:fillRef>
+          <a:effectRef idx="2">
+            <a:schemeClr val="accent1"/>
+          </a:effectRef>
+          <a:fontRef idx="minor">
+            <a:schemeClr val="lt1"/>
+          </a:fontRef>
+        </p:style>
+        <p:txBody>
+          <a:bodyPr rtlCol="0" anchor="ctr"/>
+          <a:lstStyle/>
+          <a:p>
+            <a:pPr algn="ctr"/>
+          </a:p>
+        </p:txBody>
+      </p:sp>
+      <p:sp>
+        <p:nvSpPr>
+          <p:cNvPr id="9" name="TextBox 8"/>
+          <p:cNvSpPr txBox="1"/>
+          <p:nvPr/>
+        </p:nvSpPr>
+        <p:spPr>
+          <a:xfrm>
+            <a:off x="2953512" y="1298448"/>
+            <a:ext cx="1728216" cy="256032"/>
+          </a:xfrm>
+          <a:prstGeom prst="rect">
+            <a:avLst/>
+          </a:prstGeom>
+          <a:noFill/>
+        </p:spPr>
+        <p:txBody>
+          <a:bodyPr wrap="none">
+            <a:spAutoFit/>
+          </a:bodyPr>
+          <a:lstStyle/>
+          <a:p>
+            <a:pPr>
+              <a:defRPr b="1" sz="1400">
+                <a:solidFill>
+                  <a:srgbClr val="E7A646"/>
+                </a:solidFill>
+              </a:defRPr>
+            </a:pPr>
+            <a:r>
+              <a:t>2. Features</a:t>
+            </a:r>
+          </a:p>
+        </p:txBody>
+      </p:sp>
+      <p:sp>
+        <p:nvSpPr>
+          <p:cNvPr id="10" name="TextBox 9"/>
+          <p:cNvSpPr txBox="1"/>
+          <p:nvPr/>
+        </p:nvSpPr>
+        <p:spPr>
+          <a:xfrm>
+            <a:off x="2953512" y="1627632"/>
+            <a:ext cx="1728216" cy="640080"/>
+          </a:xfrm>
+          <a:prstGeom prst="rect">
+            <a:avLst/>
+          </a:prstGeom>
+          <a:noFill/>
+        </p:spPr>
+        <p:txBody>
+          <a:bodyPr wrap="none">
+            <a:spAutoFit/>
+          </a:bodyPr>
+          <a:lstStyle/>
+          <a:p>
+            <a:pPr>
+              <a:defRPr sz="1100">
+                <a:solidFill>
+                  <a:srgbClr val="1C232B"/>
+                </a:solidFill>
+              </a:defRPr>
+            </a:pPr>
+            <a:r>
+              <a:t>The bridge converts ELK docs into model feature rows.</a:t>
+            </a:r>
+          </a:p>
+        </p:txBody>
+      </p:sp>
+      <p:sp>
+        <p:nvSpPr>
+          <p:cNvPr id="11" name="Rounded Rectangle 10"/>
+          <p:cNvSpPr/>
+          <p:nvPr/>
+        </p:nvSpPr>
+        <p:spPr>
+          <a:xfrm>
+            <a:off x="4983480" y="1188720"/>
+            <a:ext cx="2057400" cy="1143000"/>
+          </a:xfrm>
+          <a:prstGeom prst="roundRect">
+            <a:avLst/>
+          </a:prstGeom>
+          <a:solidFill>
+            <a:srgbClr val="F7F9FA"/>
+          </a:solidFill>
+          <a:ln w="19050">
+            <a:solidFill>
+              <a:srgbClr val="3D8E6D"/>
+            </a:solidFill>
+          </a:ln>
+        </p:spPr>
+        <p:style>
+          <a:lnRef idx="1">
+            <a:schemeClr val="accent1"/>
+          </a:lnRef>
+          <a:fillRef idx="3">
+            <a:schemeClr val="accent1"/>
+          </a:fillRef>
+          <a:effectRef idx="2">
+            <a:schemeClr val="accent1"/>
+          </a:effectRef>
+          <a:fontRef idx="minor">
+            <a:schemeClr val="lt1"/>
+          </a:fontRef>
+        </p:style>
+        <p:txBody>
+          <a:bodyPr rtlCol="0" anchor="ctr"/>
+          <a:lstStyle/>
+          <a:p>
+            <a:pPr algn="ctr"/>
+          </a:p>
+        </p:txBody>
+      </p:sp>
+      <p:sp>
+        <p:nvSpPr>
+          <p:cNvPr id="12" name="TextBox 11"/>
+          <p:cNvSpPr txBox="1"/>
+          <p:nvPr/>
+        </p:nvSpPr>
+        <p:spPr>
+          <a:xfrm>
+            <a:off x="5148072" y="1298448"/>
+            <a:ext cx="1728216" cy="256032"/>
+          </a:xfrm>
+          <a:prstGeom prst="rect">
+            <a:avLst/>
+          </a:prstGeom>
+          <a:noFill/>
+        </p:spPr>
+        <p:txBody>
+          <a:bodyPr wrap="none">
+            <a:spAutoFit/>
+          </a:bodyPr>
+          <a:lstStyle/>
+          <a:p>
+            <a:pPr>
+              <a:defRPr b="1" sz="1400">
+                <a:solidFill>
+                  <a:srgbClr val="3D8E6D"/>
+                </a:solidFill>
+              </a:defRPr>
+            </a:pPr>
+            <a:r>
+              <a:t>3. Scoring</a:t>
+            </a:r>
+          </a:p>
+        </p:txBody>
+      </p:sp>
+      <p:sp>
+        <p:nvSpPr>
+          <p:cNvPr id="13" name="TextBox 12"/>
+          <p:cNvSpPr txBox="1"/>
+          <p:nvPr/>
+        </p:nvSpPr>
+        <p:spPr>
+          <a:xfrm>
+            <a:off x="5148072" y="1627632"/>
+            <a:ext cx="1728216" cy="640080"/>
+          </a:xfrm>
+          <a:prstGeom prst="rect">
+            <a:avLst/>
+          </a:prstGeom>
+          <a:noFill/>
+        </p:spPr>
+        <p:txBody>
+          <a:bodyPr wrap="none">
+            <a:spAutoFit/>
+          </a:bodyPr>
+          <a:lstStyle/>
+          <a:p>
+            <a:pPr>
+              <a:defRPr sz="1100">
+                <a:solidFill>
+                  <a:srgbClr val="1C232B"/>
+                </a:solidFill>
+              </a:defRPr>
+            </a:pPr>
+            <a:r>
+              <a:t>Binary model first; attack rows go to specialists.</a:t>
+            </a:r>
+          </a:p>
+        </p:txBody>
+      </p:sp>
+      <p:sp>
+        <p:nvSpPr>
+          <p:cNvPr id="14" name="Rounded Rectangle 13"/>
+          <p:cNvSpPr/>
+          <p:nvPr/>
+        </p:nvSpPr>
+        <p:spPr>
+          <a:xfrm>
+            <a:off x="7178040" y="1188720"/>
+            <a:ext cx="2057400" cy="1143000"/>
+          </a:xfrm>
+          <a:prstGeom prst="roundRect">
+            <a:avLst/>
+          </a:prstGeom>
+          <a:solidFill>
+            <a:srgbClr val="F7F9FA"/>
+          </a:solidFill>
+          <a:ln w="19050">
+            <a:solidFill>
+              <a:srgbClr val="CC5048"/>
+            </a:solidFill>
+          </a:ln>
+        </p:spPr>
+        <p:style>
+          <a:lnRef idx="1">
+            <a:schemeClr val="accent1"/>
+          </a:lnRef>
+          <a:fillRef idx="3">
+            <a:schemeClr val="accent1"/>
+          </a:fillRef>
+          <a:effectRef idx="2">
+            <a:schemeClr val="accent1"/>
+          </a:effectRef>
+          <a:fontRef idx="minor">
+            <a:schemeClr val="lt1"/>
+          </a:fontRef>
+        </p:style>
+        <p:txBody>
+          <a:bodyPr rtlCol="0" anchor="ctr"/>
+          <a:lstStyle/>
+          <a:p>
+            <a:pPr algn="ctr"/>
+          </a:p>
+        </p:txBody>
+      </p:sp>
+      <p:sp>
+        <p:nvSpPr>
+          <p:cNvPr id="15" name="TextBox 14"/>
+          <p:cNvSpPr txBox="1"/>
+          <p:nvPr/>
+        </p:nvSpPr>
+        <p:spPr>
+          <a:xfrm>
+            <a:off x="7342631" y="1298448"/>
+            <a:ext cx="1728216" cy="256032"/>
+          </a:xfrm>
+          <a:prstGeom prst="rect">
+            <a:avLst/>
+          </a:prstGeom>
+          <a:noFill/>
+        </p:spPr>
+        <p:txBody>
+          <a:bodyPr wrap="none">
+            <a:spAutoFit/>
+          </a:bodyPr>
+          <a:lstStyle/>
+          <a:p>
+            <a:pPr>
+              <a:defRPr b="1" sz="1400">
+                <a:solidFill>
+                  <a:srgbClr val="CC5048"/>
+                </a:solidFill>
+              </a:defRPr>
+            </a:pPr>
+            <a:r>
+              <a:t>4. Write Back</a:t>
+            </a:r>
+          </a:p>
+        </p:txBody>
+      </p:sp>
+      <p:sp>
+        <p:nvSpPr>
+          <p:cNvPr id="16" name="TextBox 15"/>
+          <p:cNvSpPr txBox="1"/>
+          <p:nvPr/>
+        </p:nvSpPr>
+        <p:spPr>
+          <a:xfrm>
+            <a:off x="7342631" y="1627632"/>
+            <a:ext cx="1728216" cy="640080"/>
+          </a:xfrm>
+          <a:prstGeom prst="rect">
+            <a:avLst/>
+          </a:prstGeom>
+          <a:noFill/>
+        </p:spPr>
+        <p:txBody>
+          <a:bodyPr wrap="none">
+            <a:spAutoFit/>
+          </a:bodyPr>
+          <a:lstStyle/>
+          <a:p>
+            <a:pPr>
+              <a:defRPr sz="1100">
+                <a:solidFill>
+                  <a:srgbClr val="1C232B"/>
+                </a:solidFill>
+              </a:defRPr>
+            </a:pPr>
+            <a:r>
+              <a:t>Predictions go to cyberlog-ml-predictions-*.</a:t>
+            </a:r>
+          </a:p>
+        </p:txBody>
+      </p:sp>
+      <p:sp>
+        <p:nvSpPr>
+          <p:cNvPr id="17" name="Rounded Rectangle 16"/>
+          <p:cNvSpPr/>
+          <p:nvPr/>
+        </p:nvSpPr>
+        <p:spPr>
+          <a:xfrm>
+            <a:off x="9372600" y="1188720"/>
+            <a:ext cx="2057400" cy="1143000"/>
+          </a:xfrm>
+          <a:prstGeom prst="roundRect">
+            <a:avLst/>
+          </a:prstGeom>
+          <a:solidFill>
+            <a:srgbClr val="F7F9FA"/>
+          </a:solidFill>
+          <a:ln w="19050">
+            <a:solidFill>
+              <a:srgbClr val="586370"/>
+            </a:solidFill>
+          </a:ln>
+        </p:spPr>
+        <p:style>
+          <a:lnRef idx="1">
+            <a:schemeClr val="accent1"/>
+          </a:lnRef>
+          <a:fillRef idx="3">
+            <a:schemeClr val="accent1"/>
+          </a:fillRef>
+          <a:effectRef idx="2">
+            <a:schemeClr val="accent1"/>
+          </a:effectRef>
+          <a:fontRef idx="minor">
+            <a:schemeClr val="lt1"/>
+          </a:fontRef>
+        </p:style>
+        <p:txBody>
+          <a:bodyPr rtlCol="0" anchor="ctr"/>
+          <a:lstStyle/>
+          <a:p>
+            <a:pPr algn="ctr"/>
+          </a:p>
+        </p:txBody>
+      </p:sp>
+      <p:sp>
+        <p:nvSpPr>
+          <p:cNvPr id="18" name="TextBox 17"/>
+          <p:cNvSpPr txBox="1"/>
+          <p:nvPr/>
+        </p:nvSpPr>
+        <p:spPr>
+          <a:xfrm>
+            <a:off x="9537192" y="1298448"/>
+            <a:ext cx="1728216" cy="256032"/>
+          </a:xfrm>
+          <a:prstGeom prst="rect">
+            <a:avLst/>
+          </a:prstGeom>
+          <a:noFill/>
+        </p:spPr>
+        <p:txBody>
+          <a:bodyPr wrap="none">
+            <a:spAutoFit/>
+          </a:bodyPr>
+          <a:lstStyle/>
+          <a:p>
+            <a:pPr>
+              <a:defRPr b="1" sz="1400">
+                <a:solidFill>
+                  <a:srgbClr val="586370"/>
+                </a:solidFill>
+              </a:defRPr>
+            </a:pPr>
+            <a:r>
+              <a:t>5. Kibana</a:t>
+            </a:r>
+          </a:p>
+        </p:txBody>
+      </p:sp>
+      <p:sp>
+        <p:nvSpPr>
+          <p:cNvPr id="19" name="TextBox 18"/>
+          <p:cNvSpPr txBox="1"/>
+          <p:nvPr/>
+        </p:nvSpPr>
+        <p:spPr>
+          <a:xfrm>
+            <a:off x="9537192" y="1627632"/>
+            <a:ext cx="1728216" cy="640080"/>
+          </a:xfrm>
+          <a:prstGeom prst="rect">
+            <a:avLst/>
+          </a:prstGeom>
+          <a:noFill/>
+        </p:spPr>
+        <p:txBody>
+          <a:bodyPr wrap="none">
+            <a:spAutoFit/>
+          </a:bodyPr>
+          <a:lstStyle/>
+          <a:p>
+            <a:pPr>
+              <a:defRPr sz="1100">
+                <a:solidFill>
+                  <a:srgbClr val="1C232B"/>
+                </a:solidFill>
+              </a:defRPr>
+            </a:pPr>
+            <a:r>
+              <a:t>Analysts filter the decision layer in Discover.</a:t>
+            </a:r>
+          </a:p>
+        </p:txBody>
+      </p:sp>
+      <p:graphicFrame>
+        <p:nvGraphicFramePr>
+          <p:cNvPr id="20" name="Table 19"/>
+          <p:cNvGraphicFramePr>
+            <a:graphicFrameLocks noGrp="1"/>
+          </p:cNvGraphicFramePr>
+          <p:nvPr/>
+        </p:nvGraphicFramePr>
+        <p:xfrm>
+          <a:off x="914400" y="3063240"/>
+          <a:ext cx="10332720" cy="1965960"/>
+        </p:xfrm>
+        <a:graphic>
+          <a:graphicData uri="http://schemas.openxmlformats.org/drawingml/2006/table">
+            <a:tbl>
+              <a:tblPr firstRow="1" bandRow="1">
+                <a:tableStyleId>{5C22544A-7EE6-4342-B048-85BDC9FD1C3A}</a:tableStyleId>
+              </a:tblPr>
+              <a:tblGrid>
+                <a:gridCol w="5166360"/>
+                <a:gridCol w="5166360"/>
+              </a:tblGrid>
+              <a:tr h="327660">
+                <a:tc>
+                  <a:txBody>
+                    <a:bodyPr/>
+                    <a:lstStyle/>
+                    <a:p>
+                      <a:pPr>
+                        <a:defRPr b="1" sz="1000">
+                          <a:solidFill>
+                            <a:srgbClr val="FFFFFF"/>
+                          </a:solidFill>
+                        </a:defRPr>
+                      </a:pPr>
+                      <a:r>
+                        <a:t>Demo output</a:t>
+                      </a:r>
+                    </a:p>
+                  </a:txBody>
+                  <a:tcPr>
+                    <a:solidFill>
+                      <a:srgbClr val="2A6F97"/>
+                    </a:solidFill>
+                  </a:tcPr>
+                </a:tc>
+                <a:tc>
+                  <a:txBody>
+                    <a:bodyPr/>
+                    <a:lstStyle/>
+                    <a:p>
+                      <a:pPr>
+                        <a:defRPr b="1" sz="1000">
+                          <a:solidFill>
+                            <a:srgbClr val="FFFFFF"/>
+                          </a:solidFill>
+                        </a:defRPr>
+                      </a:pPr>
+                      <a:r>
+                        <a:t>Result</a:t>
+                      </a:r>
+                    </a:p>
+                  </a:txBody>
+                  <a:tcPr>
+                    <a:solidFill>
+                      <a:srgbClr val="2A6F97"/>
+                    </a:solidFill>
+                  </a:tcPr>
+                </a:tc>
+              </a:tr>
+              <a:tr h="327660">
+                <a:tc>
+                  <a:txBody>
+                    <a:bodyPr/>
+                    <a:lstStyle/>
+                    <a:p>
+                      <a:pPr>
+                        <a:defRPr sz="900">
+                          <a:solidFill>
+                            <a:srgbClr val="1C232B"/>
+                          </a:solidFill>
+                        </a:defRPr>
+                      </a:pPr>
+                      <a:r>
+                        <a:t>Input ELK events</a:t>
+                      </a:r>
+                    </a:p>
+                  </a:txBody>
+                  <a:tcPr>
+                    <a:solidFill>
+                      <a:srgbClr val="FFFFFF"/>
+                    </a:solidFill>
+                  </a:tcPr>
+                </a:tc>
+                <a:tc>
+                  <a:txBody>
+                    <a:bodyPr/>
+                    <a:lstStyle/>
+                    <a:p>
+                      <a:pPr>
+                        <a:defRPr sz="900">
+                          <a:solidFill>
+                            <a:srgbClr val="1C232B"/>
+                          </a:solidFill>
+                        </a:defRPr>
+                      </a:pPr>
+                      <a:r>
+                        <a:t>15</a:t>
+                      </a:r>
+                    </a:p>
+                  </a:txBody>
+                  <a:tcPr>
+                    <a:solidFill>
+                      <a:srgbClr val="FFFFFF"/>
+                    </a:solidFill>
+                  </a:tcPr>
+                </a:tc>
+              </a:tr>
+              <a:tr h="327660">
+                <a:tc>
+                  <a:txBody>
+                    <a:bodyPr/>
+                    <a:lstStyle/>
+                    <a:p>
+                      <a:pPr>
+                        <a:defRPr sz="900">
+                          <a:solidFill>
+                            <a:srgbClr val="1C232B"/>
+                          </a:solidFill>
+                        </a:defRPr>
+                      </a:pPr>
+                      <a:r>
+                        <a:t>Prediction documents</a:t>
+                      </a:r>
+                    </a:p>
+                  </a:txBody>
+                  <a:tcPr>
+                    <a:solidFill>
+                      <a:srgbClr val="F7F9FA"/>
+                    </a:solidFill>
+                  </a:tcPr>
+                </a:tc>
+                <a:tc>
+                  <a:txBody>
+                    <a:bodyPr/>
+                    <a:lstStyle/>
+                    <a:p>
+                      <a:pPr>
+                        <a:defRPr sz="900">
+                          <a:solidFill>
+                            <a:srgbClr val="1C232B"/>
+                          </a:solidFill>
+                        </a:defRPr>
+                      </a:pPr>
+                      <a:r>
+                        <a:t>15</a:t>
+                      </a:r>
+                    </a:p>
+                  </a:txBody>
+                  <a:tcPr>
+                    <a:solidFill>
+                      <a:srgbClr val="F7F9FA"/>
+                    </a:solidFill>
+                  </a:tcPr>
+                </a:tc>
+              </a:tr>
+              <a:tr h="327660">
+                <a:tc>
+                  <a:txBody>
+                    <a:bodyPr/>
+                    <a:lstStyle/>
+                    <a:p>
+                      <a:pPr>
+                        <a:defRPr sz="900">
+                          <a:solidFill>
+                            <a:srgbClr val="1C232B"/>
+                          </a:solidFill>
+                        </a:defRPr>
+                      </a:pPr>
+                      <a:r>
+                        <a:t>Predicted attacks</a:t>
+                      </a:r>
+                    </a:p>
+                  </a:txBody>
+                  <a:tcPr>
+                    <a:solidFill>
+                      <a:srgbClr val="FFFFFF"/>
+                    </a:solidFill>
+                  </a:tcPr>
+                </a:tc>
+                <a:tc>
+                  <a:txBody>
+                    <a:bodyPr/>
+                    <a:lstStyle/>
+                    <a:p>
+                      <a:pPr>
+                        <a:defRPr sz="900">
+                          <a:solidFill>
+                            <a:srgbClr val="1C232B"/>
+                          </a:solidFill>
+                        </a:defRPr>
+                      </a:pPr>
+                      <a:r>
+                        <a:t>8</a:t>
+                      </a:r>
+                    </a:p>
+                  </a:txBody>
+                  <a:tcPr>
+                    <a:solidFill>
+                      <a:srgbClr val="FFFFFF"/>
+                    </a:solidFill>
+                  </a:tcPr>
+                </a:tc>
+              </a:tr>
+              <a:tr h="327660">
+                <a:tc>
+                  <a:txBody>
+                    <a:bodyPr/>
+                    <a:lstStyle/>
+                    <a:p>
+                      <a:pPr>
+                        <a:defRPr sz="900">
+                          <a:solidFill>
+                            <a:srgbClr val="1C232B"/>
+                          </a:solidFill>
+                        </a:defRPr>
+                      </a:pPr>
+                      <a:r>
+                        <a:t>Predicted normal</a:t>
+                      </a:r>
+                    </a:p>
+                  </a:txBody>
+                  <a:tcPr>
+                    <a:solidFill>
+                      <a:srgbClr val="F7F9FA"/>
+                    </a:solidFill>
+                  </a:tcPr>
+                </a:tc>
+                <a:tc>
+                  <a:txBody>
+                    <a:bodyPr/>
+                    <a:lstStyle/>
+                    <a:p>
+                      <a:pPr>
+                        <a:defRPr sz="900">
+                          <a:solidFill>
+                            <a:srgbClr val="1C232B"/>
+                          </a:solidFill>
+                        </a:defRPr>
+                      </a:pPr>
+                      <a:r>
+                        <a:t>7</a:t>
+                      </a:r>
+                    </a:p>
+                  </a:txBody>
+                  <a:tcPr>
+                    <a:solidFill>
+                      <a:srgbClr val="F7F9FA"/>
+                    </a:solidFill>
+                  </a:tcPr>
+                </a:tc>
+              </a:tr>
+              <a:tr h="327660">
+                <a:tc>
+                  <a:txBody>
+                    <a:bodyPr/>
+                    <a:lstStyle/>
+                    <a:p>
+                      <a:pPr>
+                        <a:defRPr sz="900">
+                          <a:solidFill>
+                            <a:srgbClr val="1C232B"/>
+                          </a:solidFill>
+                        </a:defRPr>
+                      </a:pPr>
+                      <a:r>
+                        <a:t>Prediction data view</a:t>
+                      </a:r>
+                    </a:p>
+                  </a:txBody>
+                  <a:tcPr>
+                    <a:solidFill>
+                      <a:srgbClr val="FFFFFF"/>
+                    </a:solidFill>
+                  </a:tcPr>
+                </a:tc>
+                <a:tc>
+                  <a:txBody>
+                    <a:bodyPr/>
+                    <a:lstStyle/>
+                    <a:p>
+                      <a:pPr>
+                        <a:defRPr sz="900">
+                          <a:solidFill>
+                            <a:srgbClr val="1C232B"/>
+                          </a:solidFill>
+                        </a:defRPr>
+                      </a:pPr>
+                      <a:r>
+                        <a:t>cyberlog-ml-predictions-*</a:t>
+                      </a:r>
+                    </a:p>
+                  </a:txBody>
+                  <a:tcPr>
+                    <a:solidFill>
+                      <a:srgbClr val="FFFFFF"/>
+                    </a:solidFill>
+                  </a:tcPr>
+                </a:tc>
+              </a:tr>
+            </a:tbl>
+          </a:graphicData>
+        </a:graphic>
+      </p:graphicFrame>
+    </p:spTree>
+  </p:cSld>
+  <p:clrMapOvr>
+    <a:masterClrMapping/>
+  </p:clrMapOvr>
+</p:sld>
+</file>
+
+<file path=ppt/slides/slide14.xml><?xml version="1.0" encoding="utf-8"?>
+<p:sld xmlns:a="http://schemas.openxmlformats.org/drawingml/2006/main" xmlns:p="http://schemas.openxmlformats.org/presentationml/2006/main" xmlns:r="http://schemas.openxmlformats.org/officeDocument/2006/relationships">
+  <p:cSld>
+    <p:spTree>
+      <p:nvGrpSpPr>
+        <p:cNvPr id="1" name=""/>
+        <p:cNvGrpSpPr/>
+        <p:nvPr/>
+      </p:nvGrpSpPr>
+      <p:grpSpPr/>
+      <p:sp>
+        <p:nvSpPr>
+          <p:cNvPr id="2" name="TextBox 1"/>
+          <p:cNvSpPr txBox="1"/>
+          <p:nvPr/>
+        </p:nvSpPr>
+        <p:spPr>
+          <a:xfrm>
+            <a:off x="502920" y="320040"/>
+            <a:ext cx="11155680" cy="548640"/>
+          </a:xfrm>
+          <a:prstGeom prst="rect">
+            <a:avLst/>
+          </a:prstGeom>
+          <a:noFill/>
+        </p:spPr>
+        <p:txBody>
+          <a:bodyPr wrap="none">
+            <a:spAutoFit/>
+          </a:bodyPr>
+          <a:lstStyle/>
+          <a:p>
+            <a:pPr>
+              <a:defRPr sz="2800" b="1">
+                <a:solidFill>
+                  <a:srgbClr val="1C232B"/>
+                </a:solidFill>
+              </a:defRPr>
+            </a:pPr>
+            <a:r>
+              <a:t>How To Demo In Kibana</a:t>
+            </a:r>
+          </a:p>
+        </p:txBody>
+      </p:sp>
+      <p:sp>
+        <p:nvSpPr>
+          <p:cNvPr id="3" name="Rectangle 2"/>
+          <p:cNvSpPr/>
+          <p:nvPr/>
+        </p:nvSpPr>
+        <p:spPr>
+          <a:xfrm>
+            <a:off x="0" y="6556248"/>
+            <a:ext cx="12188952" cy="36576"/>
+          </a:xfrm>
+          <a:prstGeom prst="rect">
+            <a:avLst/>
+          </a:prstGeom>
+          <a:solidFill>
+            <a:srgbClr val="D2D8DE"/>
+          </a:solidFill>
+          <a:ln>
+            <a:noFill/>
+          </a:ln>
+        </p:spPr>
+        <p:style>
+          <a:lnRef idx="1">
+            <a:schemeClr val="accent1"/>
+          </a:lnRef>
+          <a:fillRef idx="3">
+            <a:schemeClr val="accent1"/>
+          </a:fillRef>
+          <a:effectRef idx="2">
+            <a:schemeClr val="accent1"/>
+          </a:effectRef>
+          <a:fontRef idx="minor">
+            <a:schemeClr val="lt1"/>
+          </a:fontRef>
+        </p:style>
+        <p:txBody>
+          <a:bodyPr rtlCol="0" anchor="ctr"/>
+          <a:lstStyle/>
+          <a:p>
+            <a:pPr algn="ctr"/>
+          </a:p>
+        </p:txBody>
+      </p:sp>
+      <p:sp>
+        <p:nvSpPr>
+          <p:cNvPr id="4" name="TextBox 3"/>
+          <p:cNvSpPr txBox="1"/>
+          <p:nvPr/>
+        </p:nvSpPr>
+        <p:spPr>
+          <a:xfrm>
+            <a:off x="502920" y="6601968"/>
+            <a:ext cx="11155680" cy="228600"/>
+          </a:xfrm>
+          <a:prstGeom prst="rect">
+            <a:avLst/>
+          </a:prstGeom>
+          <a:noFill/>
+        </p:spPr>
+        <p:txBody>
+          <a:bodyPr wrap="none">
+            <a:spAutoFit/>
+          </a:bodyPr>
+          <a:lstStyle/>
+          <a:p>
+            <a:pPr>
+              <a:defRPr sz="800">
+                <a:solidFill>
+                  <a:srgbClr val="586370"/>
+                </a:solidFill>
+              </a:defRPr>
+            </a:pPr>
+            <a:r>
+              <a:t>Cyber Log Attack Detection | 14</a:t>
+            </a:r>
+          </a:p>
+        </p:txBody>
+      </p:sp>
+      <p:graphicFrame>
+        <p:nvGraphicFramePr>
+          <p:cNvPr id="5" name="Table 4"/>
+          <p:cNvGraphicFramePr>
+            <a:graphicFrameLocks noGrp="1"/>
+          </p:cNvGraphicFramePr>
+          <p:nvPr/>
+        </p:nvGraphicFramePr>
+        <p:xfrm>
+          <a:off x="685800" y="1234440"/>
+          <a:ext cx="10881360" cy="2057400"/>
+        </p:xfrm>
+        <a:graphic>
+          <a:graphicData uri="http://schemas.openxmlformats.org/drawingml/2006/table">
+            <a:tbl>
+              <a:tblPr firstRow="1" bandRow="1">
+                <a:tableStyleId>{5C22544A-7EE6-4342-B048-85BDC9FD1C3A}</a:tableStyleId>
+              </a:tblPr>
+              <a:tblGrid>
+                <a:gridCol w="3627120"/>
+                <a:gridCol w="3627120"/>
+                <a:gridCol w="3627120"/>
+              </a:tblGrid>
+              <a:tr h="514350">
+                <a:tc>
+                  <a:txBody>
+                    <a:bodyPr/>
+                    <a:lstStyle/>
+                    <a:p>
+                      <a:pPr>
+                        <a:defRPr b="1" sz="1000">
+                          <a:solidFill>
+                            <a:srgbClr val="FFFFFF"/>
+                          </a:solidFill>
+                        </a:defRPr>
+                      </a:pPr>
+                      <a:r>
+                        <a:t>Kibana data view</a:t>
+                      </a:r>
+                    </a:p>
+                  </a:txBody>
+                  <a:tcPr>
+                    <a:solidFill>
+                      <a:srgbClr val="2A6F97"/>
+                    </a:solidFill>
+                  </a:tcPr>
+                </a:tc>
+                <a:tc>
+                  <a:txBody>
+                    <a:bodyPr/>
+                    <a:lstStyle/>
+                    <a:p>
+                      <a:pPr>
+                        <a:defRPr b="1" sz="1000">
+                          <a:solidFill>
+                            <a:srgbClr val="FFFFFF"/>
+                          </a:solidFill>
+                        </a:defRPr>
+                      </a:pPr>
+                      <a:r>
+                        <a:t>What it shows</a:t>
+                      </a:r>
+                    </a:p>
+                  </a:txBody>
+                  <a:tcPr>
+                    <a:solidFill>
+                      <a:srgbClr val="2A6F97"/>
+                    </a:solidFill>
+                  </a:tcPr>
+                </a:tc>
+                <a:tc>
+                  <a:txBody>
+                    <a:bodyPr/>
+                    <a:lstStyle/>
+                    <a:p>
+                      <a:pPr>
+                        <a:defRPr b="1" sz="1000">
+                          <a:solidFill>
+                            <a:srgbClr val="FFFFFF"/>
+                          </a:solidFill>
+                        </a:defRPr>
+                      </a:pPr>
+                      <a:r>
+                        <a:t>Useful filters</a:t>
+                      </a:r>
+                    </a:p>
+                  </a:txBody>
+                  <a:tcPr>
+                    <a:solidFill>
+                      <a:srgbClr val="2A6F97"/>
+                    </a:solidFill>
+                  </a:tcPr>
+                </a:tc>
+              </a:tr>
+              <a:tr h="514350">
+                <a:tc>
+                  <a:txBody>
+                    <a:bodyPr/>
+                    <a:lstStyle/>
+                    <a:p>
+                      <a:pPr>
+                        <a:defRPr sz="900">
+                          <a:solidFill>
+                            <a:srgbClr val="1C232B"/>
+                          </a:solidFill>
+                        </a:defRPr>
+                      </a:pPr>
+                      <a:r>
+                        <a:t>Cyber Log Events</a:t>
+                      </a:r>
+                    </a:p>
+                  </a:txBody>
+                  <a:tcPr>
+                    <a:solidFill>
+                      <a:srgbClr val="FFFFFF"/>
+                    </a:solidFill>
+                  </a:tcPr>
+                </a:tc>
+                <a:tc>
+                  <a:txBody>
+                    <a:bodyPr/>
+                    <a:lstStyle/>
+                    <a:p>
+                      <a:pPr>
+                        <a:defRPr sz="900">
+                          <a:solidFill>
+                            <a:srgbClr val="1C232B"/>
+                          </a:solidFill>
+                        </a:defRPr>
+                      </a:pPr>
+                      <a:r>
+                        <a:t>Raw parsed SSH/web/firewall events</a:t>
+                      </a:r>
+                    </a:p>
+                  </a:txBody>
+                  <a:tcPr>
+                    <a:solidFill>
+                      <a:srgbClr val="FFFFFF"/>
+                    </a:solidFill>
+                  </a:tcPr>
+                </a:tc>
+                <a:tc>
+                  <a:txBody>
+                    <a:bodyPr/>
+                    <a:lstStyle/>
+                    <a:p>
+                      <a:pPr>
+                        <a:defRPr sz="900">
+                          <a:solidFill>
+                            <a:srgbClr val="1C232B"/>
+                          </a:solidFill>
+                        </a:defRPr>
+                      </a:pPr>
+                      <a:r>
+                        <a:t>log_source: ssh</a:t>
+                      </a:r>
+                    </a:p>
+                  </a:txBody>
+                  <a:tcPr>
+                    <a:solidFill>
+                      <a:srgbClr val="FFFFFF"/>
+                    </a:solidFill>
+                  </a:tcPr>
+                </a:tc>
+              </a:tr>
+              <a:tr h="514350">
+                <a:tc>
+                  <a:txBody>
+                    <a:bodyPr/>
+                    <a:lstStyle/>
+                    <a:p>
+                      <a:pPr>
+                        <a:defRPr sz="900">
+                          <a:solidFill>
+                            <a:srgbClr val="1C232B"/>
+                          </a:solidFill>
+                        </a:defRPr>
+                      </a:pPr>
+                      <a:r>
+                        <a:t>Cyber Log ML Predictions</a:t>
+                      </a:r>
+                    </a:p>
+                  </a:txBody>
+                  <a:tcPr>
+                    <a:solidFill>
+                      <a:srgbClr val="F7F9FA"/>
+                    </a:solidFill>
+                  </a:tcPr>
+                </a:tc>
+                <a:tc>
+                  <a:txBody>
+                    <a:bodyPr/>
+                    <a:lstStyle/>
+                    <a:p>
+                      <a:pPr>
+                        <a:defRPr sz="900">
+                          <a:solidFill>
+                            <a:srgbClr val="1C232B"/>
+                          </a:solidFill>
+                        </a:defRPr>
+                      </a:pPr>
+                      <a:r>
+                        <a:t>Model predictions written back to Elasticsearch</a:t>
+                      </a:r>
+                    </a:p>
+                  </a:txBody>
+                  <a:tcPr>
+                    <a:solidFill>
+                      <a:srgbClr val="F7F9FA"/>
+                    </a:solidFill>
+                  </a:tcPr>
+                </a:tc>
+                <a:tc>
+                  <a:txBody>
+                    <a:bodyPr/>
+                    <a:lstStyle/>
+                    <a:p>
+                      <a:pPr>
+                        <a:defRPr sz="900">
+                          <a:solidFill>
+                            <a:srgbClr val="1C232B"/>
+                          </a:solidFill>
+                        </a:defRPr>
+                      </a:pPr>
+                      <a:r>
+                        <a:t>ml.predicted_binary_label: attack</a:t>
+                      </a:r>
+                    </a:p>
+                  </a:txBody>
+                  <a:tcPr>
+                    <a:solidFill>
+                      <a:srgbClr val="F7F9FA"/>
+                    </a:solidFill>
+                  </a:tcPr>
+                </a:tc>
+              </a:tr>
+              <a:tr h="514350">
+                <a:tc>
+                  <a:txBody>
+                    <a:bodyPr/>
+                    <a:lstStyle/>
+                    <a:p>
+                      <a:pPr>
+                        <a:defRPr sz="900">
+                          <a:solidFill>
+                            <a:srgbClr val="1C232B"/>
+                          </a:solidFill>
+                        </a:defRPr>
+                      </a:pPr>
+                      <a:r>
+                        <a:t>Cyber Log ML Predictions</a:t>
+                      </a:r>
+                    </a:p>
+                  </a:txBody>
+                  <a:tcPr>
+                    <a:solidFill>
+                      <a:srgbClr val="FFFFFF"/>
+                    </a:solidFill>
+                  </a:tcPr>
+                </a:tc>
+                <a:tc>
+                  <a:txBody>
+                    <a:bodyPr/>
+                    <a:lstStyle/>
+                    <a:p>
+                      <a:pPr>
+                        <a:defRPr sz="900">
+                          <a:solidFill>
+                            <a:srgbClr val="1C232B"/>
+                          </a:solidFill>
+                        </a:defRPr>
+                      </a:pPr>
+                      <a:r>
+                        <a:t>Attack category diagnosis</a:t>
+                      </a:r>
+                    </a:p>
+                  </a:txBody>
+                  <a:tcPr>
+                    <a:solidFill>
+                      <a:srgbClr val="FFFFFF"/>
+                    </a:solidFill>
+                  </a:tcPr>
+                </a:tc>
+                <a:tc>
+                  <a:txBody>
+                    <a:bodyPr/>
+                    <a:lstStyle/>
+                    <a:p>
+                      <a:pPr>
+                        <a:defRPr sz="900">
+                          <a:solidFill>
+                            <a:srgbClr val="1C232B"/>
+                          </a:solidFill>
+                        </a:defRPr>
+                      </a:pPr>
+                      <a:r>
+                        <a:t>ml.predicted_attack_category: firewall_block</a:t>
+                      </a:r>
+                    </a:p>
+                  </a:txBody>
+                  <a:tcPr>
+                    <a:solidFill>
+                      <a:srgbClr val="FFFFFF"/>
+                    </a:solidFill>
+                  </a:tcPr>
+                </a:tc>
+              </a:tr>
+            </a:tbl>
+          </a:graphicData>
+        </a:graphic>
+      </p:graphicFrame>
+      <p:sp>
+        <p:nvSpPr>
+          <p:cNvPr id="6" name="TextBox 5"/>
+          <p:cNvSpPr txBox="1"/>
+          <p:nvPr/>
+        </p:nvSpPr>
+        <p:spPr>
+          <a:xfrm>
+            <a:off x="914400" y="3886200"/>
+            <a:ext cx="10241280" cy="1554480"/>
+          </a:xfrm>
+          <a:prstGeom prst="rect">
+            <a:avLst/>
+          </a:prstGeom>
+          <a:noFill/>
+        </p:spPr>
+        <p:txBody>
+          <a:bodyPr wrap="none">
+            <a:spAutoFit/>
+          </a:bodyPr>
+          <a:lstStyle/>
+          <a:p>
+            <a:pPr>
+              <a:spcAft>
+                <a:spcPts val="800"/>
+              </a:spcAft>
+              <a:defRPr sz="1700">
+                <a:solidFill>
+                  <a:srgbClr val="1C232B"/>
+                </a:solidFill>
+              </a:defRPr>
+            </a:pPr>
+            <a:r>
+              <a:t>This makes the demo feel operational: first inspect the original logs, then inspect the model's decision layer.</a:t>
+            </a:r>
+          </a:p>
+          <a:p>
+            <a:pPr>
+              <a:spcAft>
+                <a:spcPts val="800"/>
+              </a:spcAft>
+              <a:defRPr sz="1700">
+                <a:solidFill>
+                  <a:srgbClr val="1C232B"/>
+                </a:solidFill>
+              </a:defRPr>
+            </a:pPr>
+            <a:r>
+              <a:t>Near-real-time demo mode is polling: score_elk_events.py --watch --interval-seconds 30.</a:t>
+            </a:r>
+          </a:p>
+          <a:p>
+            <a:pPr>
+              <a:spcAft>
+                <a:spcPts val="800"/>
+              </a:spcAft>
+              <a:defRPr sz="1700">
+                <a:solidFill>
+                  <a:srgbClr val="1C232B"/>
+                </a:solidFill>
+              </a:defRPr>
+            </a:pPr>
+            <a:r>
+              <a:t>Production would turn the polling bridge into a service, queue consumer, or streaming scorer.</a:t>
+            </a:r>
+          </a:p>
+        </p:txBody>
+      </p:sp>
+    </p:spTree>
+  </p:cSld>
+  <p:clrMapOvr>
+    <a:masterClrMapping/>
+  </p:clrMapOvr>
+</p:sld>
+</file>
+
+<file path=ppt/slides/slide15.xml><?xml version="1.0" encoding="utf-8"?>
+<p:sld xmlns:a="http://schemas.openxmlformats.org/drawingml/2006/main" xmlns:p="http://schemas.openxmlformats.org/presentationml/2006/main" xmlns:r="http://schemas.openxmlformats.org/officeDocument/2006/relationships">
+  <p:cSld>
+    <p:spTree>
+      <p:nvGrpSpPr>
+        <p:cNvPr id="1" name=""/>
+        <p:cNvGrpSpPr/>
+        <p:nvPr/>
+      </p:nvGrpSpPr>
+      <p:grpSpPr/>
+      <p:sp>
+        <p:nvSpPr>
+          <p:cNvPr id="2" name="TextBox 1"/>
+          <p:cNvSpPr txBox="1"/>
+          <p:nvPr/>
+        </p:nvSpPr>
+        <p:spPr>
+          <a:xfrm>
+            <a:off x="502920" y="320040"/>
+            <a:ext cx="11155680" cy="548640"/>
+          </a:xfrm>
+          <a:prstGeom prst="rect">
+            <a:avLst/>
+          </a:prstGeom>
+          <a:noFill/>
+        </p:spPr>
+        <p:txBody>
+          <a:bodyPr wrap="none">
+            <a:spAutoFit/>
+          </a:bodyPr>
+          <a:lstStyle/>
+          <a:p>
+            <a:pPr>
+              <a:defRPr sz="2800" b="1">
+                <a:solidFill>
+                  <a:srgbClr val="1C232B"/>
+                </a:solidFill>
+              </a:defRPr>
+            </a:pPr>
+            <a:r>
+              <a:t>Limitations</a:t>
+            </a:r>
+          </a:p>
+        </p:txBody>
+      </p:sp>
+      <p:sp>
+        <p:nvSpPr>
+          <p:cNvPr id="3" name="Rectangle 2"/>
+          <p:cNvSpPr/>
+          <p:nvPr/>
+        </p:nvSpPr>
+        <p:spPr>
+          <a:xfrm>
+            <a:off x="0" y="6556248"/>
+            <a:ext cx="12188952" cy="36576"/>
+          </a:xfrm>
+          <a:prstGeom prst="rect">
+            <a:avLst/>
+          </a:prstGeom>
+          <a:solidFill>
+            <a:srgbClr val="D2D8DE"/>
+          </a:solidFill>
+          <a:ln>
+            <a:noFill/>
+          </a:ln>
+        </p:spPr>
+        <p:style>
+          <a:lnRef idx="1">
+            <a:schemeClr val="accent1"/>
+          </a:lnRef>
+          <a:fillRef idx="3">
+            <a:schemeClr val="accent1"/>
+          </a:fillRef>
+          <a:effectRef idx="2">
+            <a:schemeClr val="accent1"/>
+          </a:effectRef>
+          <a:fontRef idx="minor">
+            <a:schemeClr val="lt1"/>
+          </a:fontRef>
+        </p:style>
+        <p:txBody>
+          <a:bodyPr rtlCol="0" anchor="ctr"/>
+          <a:lstStyle/>
+          <a:p>
+            <a:pPr algn="ctr"/>
+          </a:p>
+        </p:txBody>
+      </p:sp>
+      <p:sp>
+        <p:nvSpPr>
+          <p:cNvPr id="4" name="TextBox 3"/>
+          <p:cNvSpPr txBox="1"/>
+          <p:nvPr/>
+        </p:nvSpPr>
+        <p:spPr>
+          <a:xfrm>
+            <a:off x="502920" y="6601968"/>
+            <a:ext cx="11155680" cy="228600"/>
+          </a:xfrm>
+          <a:prstGeom prst="rect">
+            <a:avLst/>
+          </a:prstGeom>
+          <a:noFill/>
+        </p:spPr>
+        <p:txBody>
+          <a:bodyPr wrap="none">
+            <a:spAutoFit/>
+          </a:bodyPr>
+          <a:lstStyle/>
+          <a:p>
+            <a:pPr>
+              <a:defRPr sz="800">
+                <a:solidFill>
+                  <a:srgbClr val="586370"/>
+                </a:solidFill>
+              </a:defRPr>
+            </a:pPr>
+            <a:r>
+              <a:t>Cyber Log Attack Detection | 15</a:t>
             </a:r>
           </a:p>
         </p:txBody>
@@ -4693,7 +7193,7 @@
 </p:sld>
 </file>
 
-<file path=ppt/slides/slide12.xml><?xml version="1.0" encoding="utf-8"?>
+<file path=ppt/slides/slide16.xml><?xml version="1.0" encoding="utf-8"?>
 <p:sld xmlns:a="http://schemas.openxmlformats.org/drawingml/2006/main" xmlns:p="http://schemas.openxmlformats.org/presentationml/2006/main" xmlns:r="http://schemas.openxmlformats.org/officeDocument/2006/relationships">
   <p:cSld>
     <p:spTree>
@@ -4811,7 +7311,7 @@
               </a:defRPr>
             </a:pPr>
             <a:r>
-              <a:t>Cyber Log Attack Detection | 12</a:t>
+              <a:t>Cyber Log Attack Detection | 16</a:t>
             </a:r>
           </a:p>
         </p:txBody>
@@ -4909,7 +7409,7 @@
               </a:defRPr>
             </a:pPr>
             <a:r>
-              <a:t>Connect ELK export or an API to the hybrid ML scorer.</a:t>
+              <a:t>Harden the ELK-to-ML bridge into a production scoring service.</a:t>
             </a:r>
           </a:p>
         </p:txBody>
@@ -4922,7 +7422,7 @@
 </p:sld>
 </file>
 
-<file path=ppt/slides/slide13.xml><?xml version="1.0" encoding="utf-8"?>
+<file path=ppt/slides/slide17.xml><?xml version="1.0" encoding="utf-8"?>
 <p:sld xmlns:a="http://schemas.openxmlformats.org/drawingml/2006/main" xmlns:p="http://schemas.openxmlformats.org/presentationml/2006/main" xmlns:r="http://schemas.openxmlformats.org/officeDocument/2006/relationships">
   <p:cSld>
     <p:spTree>
@@ -5040,7 +7540,7 @@
               </a:defRPr>
             </a:pPr>
             <a:r>
-              <a:t>Cyber Log Attack Detection | 13</a:t>
+              <a:t>Cyber Log Attack Detection | 17</a:t>
             </a:r>
           </a:p>
         </p:txBody>
@@ -5075,7 +7575,7 @@
               </a:defRPr>
             </a:pPr>
             <a:r>
-              <a:t>This project demonstrates a complete cybersecurity log ML pipeline: public and synthetic data, normalization, EDA, supervised modeling, unified vs specialist comparison, scenario testing, and ELK ingestion. The next step is validation on real analyst-labeled operational logs.</a:t>
+              <a:t>This project tells a complete security analytics story: collect logs, understand the data, train models, compare architectures, score live ELK events, and bring predictions back to Kibana. The next step is validating the same workflow on real analyst-labeled operational logs.</a:t>
             </a:r>
           </a:p>
         </p:txBody>
@@ -5128,7 +7628,7 @@
               </a:defRPr>
             </a:pPr>
             <a:r>
-              <a:t>Problem And Goal</a:t>
+              <a:t>Why This Matters</a:t>
             </a:r>
           </a:p>
         </p:txBody>
@@ -5219,8 +7719,8 @@
         </p:nvSpPr>
         <p:spPr>
           <a:xfrm>
-            <a:off x="822960" y="1325880"/>
-            <a:ext cx="10698480" cy="4297680"/>
+            <a:off x="822960" y="1234440"/>
+            <a:ext cx="10789920" cy="4389120"/>
           </a:xfrm>
           <a:prstGeom prst="rect">
             <a:avLst/>
@@ -5244,7 +7744,7 @@
               </a:defRPr>
             </a:pPr>
             <a:r>
-              <a:t>Security teams receive noisy SSH, web, and firewall logs.</a:t>
+              <a:t>Most attacks leave traces before they become obvious incidents: failed logins, scanner paths, denied ports, unusual outbound traffic.</a:t>
             </a:r>
           </a:p>
           <a:p>
@@ -5259,7 +7759,7 @@
               </a:defRPr>
             </a:pPr>
             <a:r>
-              <a:t>A single log line is not always enough; context and source type matter.</a:t>
+              <a:t>The challenge is not lack of logs. The challenge is turning thousands of raw lines into useful security decisions.</a:t>
             </a:r>
           </a:p>
           <a:p>
@@ -5274,7 +7774,7 @@
               </a:defRPr>
             </a:pPr>
             <a:r>
-              <a:t>Goal: build a repeatable data-science pipeline from logs to EDA, modeling, evaluation, and demo scoring.</a:t>
+              <a:t>A good detection system reduces alert fatigue by separating normal noise from events worth investigating.</a:t>
             </a:r>
           </a:p>
           <a:p>
@@ -5289,7 +7789,7 @@
               </a:defRPr>
             </a:pPr>
             <a:r>
-              <a:t>Output: normal vs attack first, attack category second.</a:t>
+              <a:t>It also gives analysts context: what happened, where it happened, and which attack family it resembles.</a:t>
             </a:r>
           </a:p>
         </p:txBody>
@@ -5342,7 +7842,7 @@
               </a:defRPr>
             </a:pPr>
             <a:r>
-              <a:t>Data Sources</a:t>
+              <a:t>Operational Problem</a:t>
             </a:r>
           </a:p>
         </p:txBody>
@@ -5421,6 +7921,979 @@
             </a:pPr>
             <a:r>
               <a:t>Cyber Log Attack Detection | 3</a:t>
+            </a:r>
+          </a:p>
+        </p:txBody>
+      </p:sp>
+      <p:sp>
+        <p:nvSpPr>
+          <p:cNvPr id="5" name="TextBox 4"/>
+          <p:cNvSpPr txBox="1"/>
+          <p:nvPr/>
+        </p:nvSpPr>
+        <p:spPr>
+          <a:xfrm>
+            <a:off x="822960" y="1325880"/>
+            <a:ext cx="10698480" cy="4297680"/>
+          </a:xfrm>
+          <a:prstGeom prst="rect">
+            <a:avLst/>
+          </a:prstGeom>
+          <a:noFill/>
+        </p:spPr>
+        <p:txBody>
+          <a:bodyPr wrap="none">
+            <a:spAutoFit/>
+          </a:bodyPr>
+          <a:lstStyle/>
+          <a:p>
+            <a:pPr>
+              <a:spcAft>
+                <a:spcPts val="800"/>
+              </a:spcAft>
+              <a:defRPr sz="1800">
+                <a:solidFill>
+                  <a:srgbClr val="1C232B"/>
+                </a:solidFill>
+              </a:defRPr>
+            </a:pPr>
+            <a:r>
+              <a:t>SSH logs show authentication attempts, but one failed password can be normal.</a:t>
+            </a:r>
+          </a:p>
+          <a:p>
+            <a:pPr>
+              <a:spcAft>
+                <a:spcPts val="800"/>
+              </a:spcAft>
+              <a:defRPr sz="1800">
+                <a:solidFill>
+                  <a:srgbClr val="1C232B"/>
+                </a:solidFill>
+              </a:defRPr>
+            </a:pPr>
+            <a:r>
+              <a:t>Web logs show every request, but only a few paths may contain SQLi, XSS, traversal, or scanner behavior.</a:t>
+            </a:r>
+          </a:p>
+          <a:p>
+            <a:pPr>
+              <a:spcAft>
+                <a:spcPts val="800"/>
+              </a:spcAft>
+              <a:defRPr sz="1800">
+                <a:solidFill>
+                  <a:srgbClr val="1C232B"/>
+                </a:solidFill>
+              </a:defRPr>
+            </a:pPr>
+            <a:r>
+              <a:t>Firewall logs show traffic decisions, but one deny is often background noise while repeated denies can indicate scanning.</a:t>
+            </a:r>
+          </a:p>
+          <a:p>
+            <a:pPr>
+              <a:spcAft>
+                <a:spcPts val="800"/>
+              </a:spcAft>
+              <a:defRPr sz="1800">
+                <a:solidFill>
+                  <a:srgbClr val="1C232B"/>
+                </a:solidFill>
+              </a:defRPr>
+            </a:pPr>
+            <a:r>
+              <a:t>The project goal is to convert these raw signals into a repeatable detection and investigation workflow.</a:t>
+            </a:r>
+          </a:p>
+        </p:txBody>
+      </p:sp>
+    </p:spTree>
+  </p:cSld>
+  <p:clrMapOvr>
+    <a:masterClrMapping/>
+  </p:clrMapOvr>
+</p:sld>
+</file>
+
+<file path=ppt/slides/slide4.xml><?xml version="1.0" encoding="utf-8"?>
+<p:sld xmlns:a="http://schemas.openxmlformats.org/drawingml/2006/main" xmlns:p="http://schemas.openxmlformats.org/presentationml/2006/main" xmlns:r="http://schemas.openxmlformats.org/officeDocument/2006/relationships">
+  <p:cSld>
+    <p:spTree>
+      <p:nvGrpSpPr>
+        <p:cNvPr id="1" name=""/>
+        <p:cNvGrpSpPr/>
+        <p:nvPr/>
+      </p:nvGrpSpPr>
+      <p:grpSpPr/>
+      <p:sp>
+        <p:nvSpPr>
+          <p:cNvPr id="2" name="TextBox 1"/>
+          <p:cNvSpPr txBox="1"/>
+          <p:nvPr/>
+        </p:nvSpPr>
+        <p:spPr>
+          <a:xfrm>
+            <a:off x="502920" y="320040"/>
+            <a:ext cx="11155680" cy="548640"/>
+          </a:xfrm>
+          <a:prstGeom prst="rect">
+            <a:avLst/>
+          </a:prstGeom>
+          <a:noFill/>
+        </p:spPr>
+        <p:txBody>
+          <a:bodyPr wrap="none">
+            <a:spAutoFit/>
+          </a:bodyPr>
+          <a:lstStyle/>
+          <a:p>
+            <a:pPr>
+              <a:defRPr sz="2800" b="1">
+                <a:solidFill>
+                  <a:srgbClr val="1C232B"/>
+                </a:solidFill>
+              </a:defRPr>
+            </a:pPr>
+            <a:r>
+              <a:t>Storyline</a:t>
+            </a:r>
+          </a:p>
+        </p:txBody>
+      </p:sp>
+      <p:sp>
+        <p:nvSpPr>
+          <p:cNvPr id="3" name="Rectangle 2"/>
+          <p:cNvSpPr/>
+          <p:nvPr/>
+        </p:nvSpPr>
+        <p:spPr>
+          <a:xfrm>
+            <a:off x="0" y="6556248"/>
+            <a:ext cx="12188952" cy="36576"/>
+          </a:xfrm>
+          <a:prstGeom prst="rect">
+            <a:avLst/>
+          </a:prstGeom>
+          <a:solidFill>
+            <a:srgbClr val="D2D8DE"/>
+          </a:solidFill>
+          <a:ln>
+            <a:noFill/>
+          </a:ln>
+        </p:spPr>
+        <p:style>
+          <a:lnRef idx="1">
+            <a:schemeClr val="accent1"/>
+          </a:lnRef>
+          <a:fillRef idx="3">
+            <a:schemeClr val="accent1"/>
+          </a:fillRef>
+          <a:effectRef idx="2">
+            <a:schemeClr val="accent1"/>
+          </a:effectRef>
+          <a:fontRef idx="minor">
+            <a:schemeClr val="lt1"/>
+          </a:fontRef>
+        </p:style>
+        <p:txBody>
+          <a:bodyPr rtlCol="0" anchor="ctr"/>
+          <a:lstStyle/>
+          <a:p>
+            <a:pPr algn="ctr"/>
+          </a:p>
+        </p:txBody>
+      </p:sp>
+      <p:sp>
+        <p:nvSpPr>
+          <p:cNvPr id="4" name="TextBox 3"/>
+          <p:cNvSpPr txBox="1"/>
+          <p:nvPr/>
+        </p:nvSpPr>
+        <p:spPr>
+          <a:xfrm>
+            <a:off x="502920" y="6601968"/>
+            <a:ext cx="11155680" cy="228600"/>
+          </a:xfrm>
+          <a:prstGeom prst="rect">
+            <a:avLst/>
+          </a:prstGeom>
+          <a:noFill/>
+        </p:spPr>
+        <p:txBody>
+          <a:bodyPr wrap="none">
+            <a:spAutoFit/>
+          </a:bodyPr>
+          <a:lstStyle/>
+          <a:p>
+            <a:pPr>
+              <a:defRPr sz="800">
+                <a:solidFill>
+                  <a:srgbClr val="586370"/>
+                </a:solidFill>
+              </a:defRPr>
+            </a:pPr>
+            <a:r>
+              <a:t>Cyber Log Attack Detection | 4</a:t>
+            </a:r>
+          </a:p>
+        </p:txBody>
+      </p:sp>
+      <p:sp>
+        <p:nvSpPr>
+          <p:cNvPr id="5" name="Rounded Rectangle 4"/>
+          <p:cNvSpPr/>
+          <p:nvPr/>
+        </p:nvSpPr>
+        <p:spPr>
+          <a:xfrm>
+            <a:off x="640080" y="1234440"/>
+            <a:ext cx="2148840" cy="1143000"/>
+          </a:xfrm>
+          <a:prstGeom prst="roundRect">
+            <a:avLst/>
+          </a:prstGeom>
+          <a:solidFill>
+            <a:srgbClr val="F7F9FA"/>
+          </a:solidFill>
+          <a:ln w="19050">
+            <a:solidFill>
+              <a:srgbClr val="2A6F97"/>
+            </a:solidFill>
+          </a:ln>
+        </p:spPr>
+        <p:style>
+          <a:lnRef idx="1">
+            <a:schemeClr val="accent1"/>
+          </a:lnRef>
+          <a:fillRef idx="3">
+            <a:schemeClr val="accent1"/>
+          </a:fillRef>
+          <a:effectRef idx="2">
+            <a:schemeClr val="accent1"/>
+          </a:effectRef>
+          <a:fontRef idx="minor">
+            <a:schemeClr val="lt1"/>
+          </a:fontRef>
+        </p:style>
+        <p:txBody>
+          <a:bodyPr rtlCol="0" anchor="ctr"/>
+          <a:lstStyle/>
+          <a:p>
+            <a:pPr algn="ctr"/>
+          </a:p>
+        </p:txBody>
+      </p:sp>
+      <p:sp>
+        <p:nvSpPr>
+          <p:cNvPr id="6" name="TextBox 5"/>
+          <p:cNvSpPr txBox="1"/>
+          <p:nvPr/>
+        </p:nvSpPr>
+        <p:spPr>
+          <a:xfrm>
+            <a:off x="804671" y="1344168"/>
+            <a:ext cx="1819656" cy="256032"/>
+          </a:xfrm>
+          <a:prstGeom prst="rect">
+            <a:avLst/>
+          </a:prstGeom>
+          <a:noFill/>
+        </p:spPr>
+        <p:txBody>
+          <a:bodyPr wrap="none">
+            <a:spAutoFit/>
+          </a:bodyPr>
+          <a:lstStyle/>
+          <a:p>
+            <a:pPr>
+              <a:defRPr b="1" sz="1400">
+                <a:solidFill>
+                  <a:srgbClr val="2A6F97"/>
+                </a:solidFill>
+              </a:defRPr>
+            </a:pPr>
+            <a:r>
+              <a:t>1. Collect</a:t>
+            </a:r>
+          </a:p>
+        </p:txBody>
+      </p:sp>
+      <p:sp>
+        <p:nvSpPr>
+          <p:cNvPr id="7" name="TextBox 6"/>
+          <p:cNvSpPr txBox="1"/>
+          <p:nvPr/>
+        </p:nvSpPr>
+        <p:spPr>
+          <a:xfrm>
+            <a:off x="804671" y="1673352"/>
+            <a:ext cx="1819656" cy="640080"/>
+          </a:xfrm>
+          <a:prstGeom prst="rect">
+            <a:avLst/>
+          </a:prstGeom>
+          <a:noFill/>
+        </p:spPr>
+        <p:txBody>
+          <a:bodyPr wrap="none">
+            <a:spAutoFit/>
+          </a:bodyPr>
+          <a:lstStyle/>
+          <a:p>
+            <a:pPr>
+              <a:defRPr sz="1100">
+                <a:solidFill>
+                  <a:srgbClr val="1C232B"/>
+                </a:solidFill>
+              </a:defRPr>
+            </a:pPr>
+            <a:r>
+              <a:t>Start with SSH, web, and firewall logs from public, synthetic, and sample ELK sources.</a:t>
+            </a:r>
+          </a:p>
+        </p:txBody>
+      </p:sp>
+      <p:sp>
+        <p:nvSpPr>
+          <p:cNvPr id="8" name="Rounded Rectangle 7"/>
+          <p:cNvSpPr/>
+          <p:nvPr/>
+        </p:nvSpPr>
+        <p:spPr>
+          <a:xfrm>
+            <a:off x="2971800" y="1234440"/>
+            <a:ext cx="2148840" cy="1143000"/>
+          </a:xfrm>
+          <a:prstGeom prst="roundRect">
+            <a:avLst/>
+          </a:prstGeom>
+          <a:solidFill>
+            <a:srgbClr val="F7F9FA"/>
+          </a:solidFill>
+          <a:ln w="19050">
+            <a:solidFill>
+              <a:srgbClr val="E7A646"/>
+            </a:solidFill>
+          </a:ln>
+        </p:spPr>
+        <p:style>
+          <a:lnRef idx="1">
+            <a:schemeClr val="accent1"/>
+          </a:lnRef>
+          <a:fillRef idx="3">
+            <a:schemeClr val="accent1"/>
+          </a:fillRef>
+          <a:effectRef idx="2">
+            <a:schemeClr val="accent1"/>
+          </a:effectRef>
+          <a:fontRef idx="minor">
+            <a:schemeClr val="lt1"/>
+          </a:fontRef>
+        </p:style>
+        <p:txBody>
+          <a:bodyPr rtlCol="0" anchor="ctr"/>
+          <a:lstStyle/>
+          <a:p>
+            <a:pPr algn="ctr"/>
+          </a:p>
+        </p:txBody>
+      </p:sp>
+      <p:sp>
+        <p:nvSpPr>
+          <p:cNvPr id="9" name="TextBox 8"/>
+          <p:cNvSpPr txBox="1"/>
+          <p:nvPr/>
+        </p:nvSpPr>
+        <p:spPr>
+          <a:xfrm>
+            <a:off x="3136392" y="1344168"/>
+            <a:ext cx="1819656" cy="256032"/>
+          </a:xfrm>
+          <a:prstGeom prst="rect">
+            <a:avLst/>
+          </a:prstGeom>
+          <a:noFill/>
+        </p:spPr>
+        <p:txBody>
+          <a:bodyPr wrap="none">
+            <a:spAutoFit/>
+          </a:bodyPr>
+          <a:lstStyle/>
+          <a:p>
+            <a:pPr>
+              <a:defRPr b="1" sz="1400">
+                <a:solidFill>
+                  <a:srgbClr val="E7A646"/>
+                </a:solidFill>
+              </a:defRPr>
+            </a:pPr>
+            <a:r>
+              <a:t>2. Understand</a:t>
+            </a:r>
+          </a:p>
+        </p:txBody>
+      </p:sp>
+      <p:sp>
+        <p:nvSpPr>
+          <p:cNvPr id="10" name="TextBox 9"/>
+          <p:cNvSpPr txBox="1"/>
+          <p:nvPr/>
+        </p:nvSpPr>
+        <p:spPr>
+          <a:xfrm>
+            <a:off x="3136392" y="1673352"/>
+            <a:ext cx="1819656" cy="640080"/>
+          </a:xfrm>
+          <a:prstGeom prst="rect">
+            <a:avLst/>
+          </a:prstGeom>
+          <a:noFill/>
+        </p:spPr>
+        <p:txBody>
+          <a:bodyPr wrap="none">
+            <a:spAutoFit/>
+          </a:bodyPr>
+          <a:lstStyle/>
+          <a:p>
+            <a:pPr>
+              <a:defRPr sz="1100">
+                <a:solidFill>
+                  <a:srgbClr val="1C232B"/>
+                </a:solidFill>
+              </a:defRPr>
+            </a:pPr>
+            <a:r>
+              <a:t>Run EDA to inspect labels, class balance, sources, and feature behavior.</a:t>
+            </a:r>
+          </a:p>
+        </p:txBody>
+      </p:sp>
+      <p:sp>
+        <p:nvSpPr>
+          <p:cNvPr id="11" name="Rounded Rectangle 10"/>
+          <p:cNvSpPr/>
+          <p:nvPr/>
+        </p:nvSpPr>
+        <p:spPr>
+          <a:xfrm>
+            <a:off x="5303520" y="1234440"/>
+            <a:ext cx="2148840" cy="1143000"/>
+          </a:xfrm>
+          <a:prstGeom prst="roundRect">
+            <a:avLst/>
+          </a:prstGeom>
+          <a:solidFill>
+            <a:srgbClr val="F7F9FA"/>
+          </a:solidFill>
+          <a:ln w="19050">
+            <a:solidFill>
+              <a:srgbClr val="3D8E6D"/>
+            </a:solidFill>
+          </a:ln>
+        </p:spPr>
+        <p:style>
+          <a:lnRef idx="1">
+            <a:schemeClr val="accent1"/>
+          </a:lnRef>
+          <a:fillRef idx="3">
+            <a:schemeClr val="accent1"/>
+          </a:fillRef>
+          <a:effectRef idx="2">
+            <a:schemeClr val="accent1"/>
+          </a:effectRef>
+          <a:fontRef idx="minor">
+            <a:schemeClr val="lt1"/>
+          </a:fontRef>
+        </p:style>
+        <p:txBody>
+          <a:bodyPr rtlCol="0" anchor="ctr"/>
+          <a:lstStyle/>
+          <a:p>
+            <a:pPr algn="ctr"/>
+          </a:p>
+        </p:txBody>
+      </p:sp>
+      <p:sp>
+        <p:nvSpPr>
+          <p:cNvPr id="12" name="TextBox 11"/>
+          <p:cNvSpPr txBox="1"/>
+          <p:nvPr/>
+        </p:nvSpPr>
+        <p:spPr>
+          <a:xfrm>
+            <a:off x="5468112" y="1344168"/>
+            <a:ext cx="1819656" cy="256032"/>
+          </a:xfrm>
+          <a:prstGeom prst="rect">
+            <a:avLst/>
+          </a:prstGeom>
+          <a:noFill/>
+        </p:spPr>
+        <p:txBody>
+          <a:bodyPr wrap="none">
+            <a:spAutoFit/>
+          </a:bodyPr>
+          <a:lstStyle/>
+          <a:p>
+            <a:pPr>
+              <a:defRPr b="1" sz="1400">
+                <a:solidFill>
+                  <a:srgbClr val="3D8E6D"/>
+                </a:solidFill>
+              </a:defRPr>
+            </a:pPr>
+            <a:r>
+              <a:t>3. Learn</a:t>
+            </a:r>
+          </a:p>
+        </p:txBody>
+      </p:sp>
+      <p:sp>
+        <p:nvSpPr>
+          <p:cNvPr id="13" name="TextBox 12"/>
+          <p:cNvSpPr txBox="1"/>
+          <p:nvPr/>
+        </p:nvSpPr>
+        <p:spPr>
+          <a:xfrm>
+            <a:off x="5468112" y="1673352"/>
+            <a:ext cx="1819656" cy="640080"/>
+          </a:xfrm>
+          <a:prstGeom prst="rect">
+            <a:avLst/>
+          </a:prstGeom>
+          <a:noFill/>
+        </p:spPr>
+        <p:txBody>
+          <a:bodyPr wrap="none">
+            <a:spAutoFit/>
+          </a:bodyPr>
+          <a:lstStyle/>
+          <a:p>
+            <a:pPr>
+              <a:defRPr sz="1100">
+                <a:solidFill>
+                  <a:srgbClr val="1C232B"/>
+                </a:solidFill>
+              </a:defRPr>
+            </a:pPr>
+            <a:r>
+              <a:t>Train unified and specialist models, then compare which design works better.</a:t>
+            </a:r>
+          </a:p>
+        </p:txBody>
+      </p:sp>
+      <p:sp>
+        <p:nvSpPr>
+          <p:cNvPr id="14" name="Rounded Rectangle 13"/>
+          <p:cNvSpPr/>
+          <p:nvPr/>
+        </p:nvSpPr>
+        <p:spPr>
+          <a:xfrm>
+            <a:off x="7635240" y="1234440"/>
+            <a:ext cx="2148840" cy="1143000"/>
+          </a:xfrm>
+          <a:prstGeom prst="roundRect">
+            <a:avLst/>
+          </a:prstGeom>
+          <a:solidFill>
+            <a:srgbClr val="F7F9FA"/>
+          </a:solidFill>
+          <a:ln w="19050">
+            <a:solidFill>
+              <a:srgbClr val="CC5048"/>
+            </a:solidFill>
+          </a:ln>
+        </p:spPr>
+        <p:style>
+          <a:lnRef idx="1">
+            <a:schemeClr val="accent1"/>
+          </a:lnRef>
+          <a:fillRef idx="3">
+            <a:schemeClr val="accent1"/>
+          </a:fillRef>
+          <a:effectRef idx="2">
+            <a:schemeClr val="accent1"/>
+          </a:effectRef>
+          <a:fontRef idx="minor">
+            <a:schemeClr val="lt1"/>
+          </a:fontRef>
+        </p:style>
+        <p:txBody>
+          <a:bodyPr rtlCol="0" anchor="ctr"/>
+          <a:lstStyle/>
+          <a:p>
+            <a:pPr algn="ctr"/>
+          </a:p>
+        </p:txBody>
+      </p:sp>
+      <p:sp>
+        <p:nvSpPr>
+          <p:cNvPr id="15" name="TextBox 14"/>
+          <p:cNvSpPr txBox="1"/>
+          <p:nvPr/>
+        </p:nvSpPr>
+        <p:spPr>
+          <a:xfrm>
+            <a:off x="7799831" y="1344168"/>
+            <a:ext cx="1819656" cy="256032"/>
+          </a:xfrm>
+          <a:prstGeom prst="rect">
+            <a:avLst/>
+          </a:prstGeom>
+          <a:noFill/>
+        </p:spPr>
+        <p:txBody>
+          <a:bodyPr wrap="none">
+            <a:spAutoFit/>
+          </a:bodyPr>
+          <a:lstStyle/>
+          <a:p>
+            <a:pPr>
+              <a:defRPr b="1" sz="1400">
+                <a:solidFill>
+                  <a:srgbClr val="CC5048"/>
+                </a:solidFill>
+              </a:defRPr>
+            </a:pPr>
+            <a:r>
+              <a:t>4. Integrate</a:t>
+            </a:r>
+          </a:p>
+        </p:txBody>
+      </p:sp>
+      <p:sp>
+        <p:nvSpPr>
+          <p:cNvPr id="16" name="TextBox 15"/>
+          <p:cNvSpPr txBox="1"/>
+          <p:nvPr/>
+        </p:nvSpPr>
+        <p:spPr>
+          <a:xfrm>
+            <a:off x="7799831" y="1673352"/>
+            <a:ext cx="1819656" cy="640080"/>
+          </a:xfrm>
+          <a:prstGeom prst="rect">
+            <a:avLst/>
+          </a:prstGeom>
+          <a:noFill/>
+        </p:spPr>
+        <p:txBody>
+          <a:bodyPr wrap="none">
+            <a:spAutoFit/>
+          </a:bodyPr>
+          <a:lstStyle/>
+          <a:p>
+            <a:pPr>
+              <a:defRPr sz="1100">
+                <a:solidFill>
+                  <a:srgbClr val="1C232B"/>
+                </a:solidFill>
+              </a:defRPr>
+            </a:pPr>
+            <a:r>
+              <a:t>Use ELK for ingestion/search and write ML predictions back to Elasticsearch.</a:t>
+            </a:r>
+          </a:p>
+        </p:txBody>
+      </p:sp>
+      <p:sp>
+        <p:nvSpPr>
+          <p:cNvPr id="17" name="Rounded Rectangle 16"/>
+          <p:cNvSpPr/>
+          <p:nvPr/>
+        </p:nvSpPr>
+        <p:spPr>
+          <a:xfrm>
+            <a:off x="9966960" y="1234440"/>
+            <a:ext cx="1828800" cy="1143000"/>
+          </a:xfrm>
+          <a:prstGeom prst="roundRect">
+            <a:avLst/>
+          </a:prstGeom>
+          <a:solidFill>
+            <a:srgbClr val="F7F9FA"/>
+          </a:solidFill>
+          <a:ln w="19050">
+            <a:solidFill>
+              <a:srgbClr val="586370"/>
+            </a:solidFill>
+          </a:ln>
+        </p:spPr>
+        <p:style>
+          <a:lnRef idx="1">
+            <a:schemeClr val="accent1"/>
+          </a:lnRef>
+          <a:fillRef idx="3">
+            <a:schemeClr val="accent1"/>
+          </a:fillRef>
+          <a:effectRef idx="2">
+            <a:schemeClr val="accent1"/>
+          </a:effectRef>
+          <a:fontRef idx="minor">
+            <a:schemeClr val="lt1"/>
+          </a:fontRef>
+        </p:style>
+        <p:txBody>
+          <a:bodyPr rtlCol="0" anchor="ctr"/>
+          <a:lstStyle/>
+          <a:p>
+            <a:pPr algn="ctr"/>
+          </a:p>
+        </p:txBody>
+      </p:sp>
+      <p:sp>
+        <p:nvSpPr>
+          <p:cNvPr id="18" name="TextBox 17"/>
+          <p:cNvSpPr txBox="1"/>
+          <p:nvPr/>
+        </p:nvSpPr>
+        <p:spPr>
+          <a:xfrm>
+            <a:off x="10131552" y="1344168"/>
+            <a:ext cx="1499616" cy="256032"/>
+          </a:xfrm>
+          <a:prstGeom prst="rect">
+            <a:avLst/>
+          </a:prstGeom>
+          <a:noFill/>
+        </p:spPr>
+        <p:txBody>
+          <a:bodyPr wrap="none">
+            <a:spAutoFit/>
+          </a:bodyPr>
+          <a:lstStyle/>
+          <a:p>
+            <a:pPr>
+              <a:defRPr b="1" sz="1400">
+                <a:solidFill>
+                  <a:srgbClr val="586370"/>
+                </a:solidFill>
+              </a:defRPr>
+            </a:pPr>
+            <a:r>
+              <a:t>5. Present</a:t>
+            </a:r>
+          </a:p>
+        </p:txBody>
+      </p:sp>
+      <p:sp>
+        <p:nvSpPr>
+          <p:cNvPr id="19" name="TextBox 18"/>
+          <p:cNvSpPr txBox="1"/>
+          <p:nvPr/>
+        </p:nvSpPr>
+        <p:spPr>
+          <a:xfrm>
+            <a:off x="10131552" y="1673352"/>
+            <a:ext cx="1499616" cy="640080"/>
+          </a:xfrm>
+          <a:prstGeom prst="rect">
+            <a:avLst/>
+          </a:prstGeom>
+          <a:noFill/>
+        </p:spPr>
+        <p:txBody>
+          <a:bodyPr wrap="none">
+            <a:spAutoFit/>
+          </a:bodyPr>
+          <a:lstStyle/>
+          <a:p>
+            <a:pPr>
+              <a:defRPr sz="1100">
+                <a:solidFill>
+                  <a:srgbClr val="1C232B"/>
+                </a:solidFill>
+              </a:defRPr>
+            </a:pPr>
+            <a:r>
+              <a:t>Show the pipeline, scenario results, limitations, and production next steps.</a:t>
+            </a:r>
+          </a:p>
+        </p:txBody>
+      </p:sp>
+      <p:sp>
+        <p:nvSpPr>
+          <p:cNvPr id="20" name="TextBox 19"/>
+          <p:cNvSpPr txBox="1"/>
+          <p:nvPr/>
+        </p:nvSpPr>
+        <p:spPr>
+          <a:xfrm>
+            <a:off x="914400" y="3246120"/>
+            <a:ext cx="10149840" cy="1371600"/>
+          </a:xfrm>
+          <a:prstGeom prst="rect">
+            <a:avLst/>
+          </a:prstGeom>
+          <a:noFill/>
+        </p:spPr>
+        <p:txBody>
+          <a:bodyPr wrap="none">
+            <a:spAutoFit/>
+          </a:bodyPr>
+          <a:lstStyle/>
+          <a:p>
+            <a:pPr>
+              <a:spcAft>
+                <a:spcPts val="800"/>
+              </a:spcAft>
+              <a:defRPr sz="2000">
+                <a:solidFill>
+                  <a:srgbClr val="1C232B"/>
+                </a:solidFill>
+              </a:defRPr>
+            </a:pPr>
+            <a:r>
+              <a:t>The presentation follows the same path as the system: logs -&gt; features -&gt; models -&gt; predictions -&gt; analyst view.</a:t>
+            </a:r>
+          </a:p>
+          <a:p>
+            <a:pPr>
+              <a:spcAft>
+                <a:spcPts val="800"/>
+              </a:spcAft>
+              <a:defRPr sz="2000">
+                <a:solidFill>
+                  <a:srgbClr val="1C232B"/>
+                </a:solidFill>
+              </a:defRPr>
+            </a:pPr>
+            <a:r>
+              <a:t>That makes the demo explainable instead of looking like a black box.</a:t>
+            </a:r>
+          </a:p>
+        </p:txBody>
+      </p:sp>
+    </p:spTree>
+  </p:cSld>
+  <p:clrMapOvr>
+    <a:masterClrMapping/>
+  </p:clrMapOvr>
+</p:sld>
+</file>
+
+<file path=ppt/slides/slide5.xml><?xml version="1.0" encoding="utf-8"?>
+<p:sld xmlns:a="http://schemas.openxmlformats.org/drawingml/2006/main" xmlns:p="http://schemas.openxmlformats.org/presentationml/2006/main" xmlns:r="http://schemas.openxmlformats.org/officeDocument/2006/relationships">
+  <p:cSld>
+    <p:spTree>
+      <p:nvGrpSpPr>
+        <p:cNvPr id="1" name=""/>
+        <p:cNvGrpSpPr/>
+        <p:nvPr/>
+      </p:nvGrpSpPr>
+      <p:grpSpPr/>
+      <p:sp>
+        <p:nvSpPr>
+          <p:cNvPr id="2" name="TextBox 1"/>
+          <p:cNvSpPr txBox="1"/>
+          <p:nvPr/>
+        </p:nvSpPr>
+        <p:spPr>
+          <a:xfrm>
+            <a:off x="502920" y="320040"/>
+            <a:ext cx="11155680" cy="548640"/>
+          </a:xfrm>
+          <a:prstGeom prst="rect">
+            <a:avLst/>
+          </a:prstGeom>
+          <a:noFill/>
+        </p:spPr>
+        <p:txBody>
+          <a:bodyPr wrap="none">
+            <a:spAutoFit/>
+          </a:bodyPr>
+          <a:lstStyle/>
+          <a:p>
+            <a:pPr>
+              <a:defRPr sz="2800" b="1">
+                <a:solidFill>
+                  <a:srgbClr val="1C232B"/>
+                </a:solidFill>
+              </a:defRPr>
+            </a:pPr>
+            <a:r>
+              <a:t>Data Sources</a:t>
+            </a:r>
+          </a:p>
+        </p:txBody>
+      </p:sp>
+      <p:sp>
+        <p:nvSpPr>
+          <p:cNvPr id="3" name="Rectangle 2"/>
+          <p:cNvSpPr/>
+          <p:nvPr/>
+        </p:nvSpPr>
+        <p:spPr>
+          <a:xfrm>
+            <a:off x="0" y="6556248"/>
+            <a:ext cx="12188952" cy="36576"/>
+          </a:xfrm>
+          <a:prstGeom prst="rect">
+            <a:avLst/>
+          </a:prstGeom>
+          <a:solidFill>
+            <a:srgbClr val="D2D8DE"/>
+          </a:solidFill>
+          <a:ln>
+            <a:noFill/>
+          </a:ln>
+        </p:spPr>
+        <p:style>
+          <a:lnRef idx="1">
+            <a:schemeClr val="accent1"/>
+          </a:lnRef>
+          <a:fillRef idx="3">
+            <a:schemeClr val="accent1"/>
+          </a:fillRef>
+          <a:effectRef idx="2">
+            <a:schemeClr val="accent1"/>
+          </a:effectRef>
+          <a:fontRef idx="minor">
+            <a:schemeClr val="lt1"/>
+          </a:fontRef>
+        </p:style>
+        <p:txBody>
+          <a:bodyPr rtlCol="0" anchor="ctr"/>
+          <a:lstStyle/>
+          <a:p>
+            <a:pPr algn="ctr"/>
+          </a:p>
+        </p:txBody>
+      </p:sp>
+      <p:sp>
+        <p:nvSpPr>
+          <p:cNvPr id="4" name="TextBox 3"/>
+          <p:cNvSpPr txBox="1"/>
+          <p:nvPr/>
+        </p:nvSpPr>
+        <p:spPr>
+          <a:xfrm>
+            <a:off x="502920" y="6601968"/>
+            <a:ext cx="11155680" cy="228600"/>
+          </a:xfrm>
+          <a:prstGeom prst="rect">
+            <a:avLst/>
+          </a:prstGeom>
+          <a:noFill/>
+        </p:spPr>
+        <p:txBody>
+          <a:bodyPr wrap="none">
+            <a:spAutoFit/>
+          </a:bodyPr>
+          <a:lstStyle/>
+          <a:p>
+            <a:pPr>
+              <a:defRPr sz="800">
+                <a:solidFill>
+                  <a:srgbClr val="586370"/>
+                </a:solidFill>
+              </a:defRPr>
+            </a:pPr>
+            <a:r>
+              <a:t>Cyber Log Attack Detection | 5</a:t>
             </a:r>
           </a:p>
         </p:txBody>
@@ -5855,7 +9328,7 @@
 </p:sld>
 </file>
 
-<file path=ppt/slides/slide4.xml><?xml version="1.0" encoding="utf-8"?>
+<file path=ppt/slides/slide6.xml><?xml version="1.0" encoding="utf-8"?>
 <p:sld xmlns:a="http://schemas.openxmlformats.org/drawingml/2006/main" xmlns:p="http://schemas.openxmlformats.org/presentationml/2006/main" xmlns:r="http://schemas.openxmlformats.org/officeDocument/2006/relationships">
   <p:cSld>
     <p:spTree>
@@ -5973,7 +9446,7 @@
               </a:defRPr>
             </a:pPr>
             <a:r>
-              <a:t>Cyber Log Attack Detection | 4</a:t>
+              <a:t>Cyber Log Attack Detection | 6</a:t>
             </a:r>
           </a:p>
         </p:txBody>
@@ -6384,7 +9857,7 @@
 </p:sld>
 </file>
 
-<file path=ppt/slides/slide5.xml><?xml version="1.0" encoding="utf-8"?>
+<file path=ppt/slides/slide7.xml><?xml version="1.0" encoding="utf-8"?>
 <p:sld xmlns:a="http://schemas.openxmlformats.org/drawingml/2006/main" xmlns:p="http://schemas.openxmlformats.org/presentationml/2006/main" xmlns:r="http://schemas.openxmlformats.org/officeDocument/2006/relationships">
   <p:cSld>
     <p:spTree>
@@ -6502,7 +9975,7 @@
               </a:defRPr>
             </a:pPr>
             <a:r>
-              <a:t>Cyber Log Attack Detection | 5</a:t>
+              <a:t>Cyber Log Attack Detection | 7</a:t>
             </a:r>
           </a:p>
         </p:txBody>
@@ -6613,7 +10086,7 @@
 </p:sld>
 </file>
 
-<file path=ppt/slides/slide6.xml><?xml version="1.0" encoding="utf-8"?>
+<file path=ppt/slides/slide8.xml><?xml version="1.0" encoding="utf-8"?>
 <p:sld xmlns:a="http://schemas.openxmlformats.org/drawingml/2006/main" xmlns:p="http://schemas.openxmlformats.org/presentationml/2006/main" xmlns:r="http://schemas.openxmlformats.org/officeDocument/2006/relationships">
   <p:cSld>
     <p:spTree>
@@ -6731,7 +10204,7 @@
               </a:defRPr>
             </a:pPr>
             <a:r>
-              <a:t>Cyber Log Attack Detection | 6</a:t>
+              <a:t>Cyber Log Attack Detection | 8</a:t>
             </a:r>
           </a:p>
         </p:txBody>
@@ -7108,7 +10581,7 @@
 </p:sld>
 </file>
 
-<file path=ppt/slides/slide7.xml><?xml version="1.0" encoding="utf-8"?>
+<file path=ppt/slides/slide9.xml><?xml version="1.0" encoding="utf-8"?>
 <p:sld xmlns:a="http://schemas.openxmlformats.org/drawingml/2006/main" xmlns:p="http://schemas.openxmlformats.org/presentationml/2006/main" xmlns:r="http://schemas.openxmlformats.org/officeDocument/2006/relationships">
   <p:cSld>
     <p:spTree>
@@ -7226,7 +10699,7 @@
               </a:defRPr>
             </a:pPr>
             <a:r>
-              <a:t>Cyber Log Attack Detection | 7</a:t>
+              <a:t>Cyber Log Attack Detection | 9</a:t>
             </a:r>
           </a:p>
         </p:txBody>
@@ -7640,972 +11113,6 @@
             </a:pPr>
             <a:r>
               <a:t>Baselines: most-frequent-class dummy models.</a:t>
-            </a:r>
-          </a:p>
-        </p:txBody>
-      </p:sp>
-    </p:spTree>
-  </p:cSld>
-  <p:clrMapOvr>
-    <a:masterClrMapping/>
-  </p:clrMapOvr>
-</p:sld>
-</file>
-
-<file path=ppt/slides/slide8.xml><?xml version="1.0" encoding="utf-8"?>
-<p:sld xmlns:a="http://schemas.openxmlformats.org/drawingml/2006/main" xmlns:p="http://schemas.openxmlformats.org/presentationml/2006/main" xmlns:r="http://schemas.openxmlformats.org/officeDocument/2006/relationships">
-  <p:cSld>
-    <p:spTree>
-      <p:nvGrpSpPr>
-        <p:cNvPr id="1" name=""/>
-        <p:cNvGrpSpPr/>
-        <p:nvPr/>
-      </p:nvGrpSpPr>
-      <p:grpSpPr/>
-      <p:sp>
-        <p:nvSpPr>
-          <p:cNvPr id="2" name="TextBox 1"/>
-          <p:cNvSpPr txBox="1"/>
-          <p:nvPr/>
-        </p:nvSpPr>
-        <p:spPr>
-          <a:xfrm>
-            <a:off x="502920" y="320040"/>
-            <a:ext cx="11155680" cy="548640"/>
-          </a:xfrm>
-          <a:prstGeom prst="rect">
-            <a:avLst/>
-          </a:prstGeom>
-          <a:noFill/>
-        </p:spPr>
-        <p:txBody>
-          <a:bodyPr wrap="none">
-            <a:spAutoFit/>
-          </a:bodyPr>
-          <a:lstStyle/>
-          <a:p>
-            <a:pPr>
-              <a:defRPr sz="2800" b="1">
-                <a:solidFill>
-                  <a:srgbClr val="1C232B"/>
-                </a:solidFill>
-              </a:defRPr>
-            </a:pPr>
-            <a:r>
-              <a:t>Results</a:t>
-            </a:r>
-          </a:p>
-        </p:txBody>
-      </p:sp>
-      <p:sp>
-        <p:nvSpPr>
-          <p:cNvPr id="3" name="Rectangle 2"/>
-          <p:cNvSpPr/>
-          <p:nvPr/>
-        </p:nvSpPr>
-        <p:spPr>
-          <a:xfrm>
-            <a:off x="0" y="6556248"/>
-            <a:ext cx="12188952" cy="36576"/>
-          </a:xfrm>
-          <a:prstGeom prst="rect">
-            <a:avLst/>
-          </a:prstGeom>
-          <a:solidFill>
-            <a:srgbClr val="D2D8DE"/>
-          </a:solidFill>
-          <a:ln>
-            <a:noFill/>
-          </a:ln>
-        </p:spPr>
-        <p:style>
-          <a:lnRef idx="1">
-            <a:schemeClr val="accent1"/>
-          </a:lnRef>
-          <a:fillRef idx="3">
-            <a:schemeClr val="accent1"/>
-          </a:fillRef>
-          <a:effectRef idx="2">
-            <a:schemeClr val="accent1"/>
-          </a:effectRef>
-          <a:fontRef idx="minor">
-            <a:schemeClr val="lt1"/>
-          </a:fontRef>
-        </p:style>
-        <p:txBody>
-          <a:bodyPr rtlCol="0" anchor="ctr"/>
-          <a:lstStyle/>
-          <a:p>
-            <a:pPr algn="ctr"/>
-          </a:p>
-        </p:txBody>
-      </p:sp>
-      <p:sp>
-        <p:nvSpPr>
-          <p:cNvPr id="4" name="TextBox 3"/>
-          <p:cNvSpPr txBox="1"/>
-          <p:nvPr/>
-        </p:nvSpPr>
-        <p:spPr>
-          <a:xfrm>
-            <a:off x="502920" y="6601968"/>
-            <a:ext cx="11155680" cy="228600"/>
-          </a:xfrm>
-          <a:prstGeom prst="rect">
-            <a:avLst/>
-          </a:prstGeom>
-          <a:noFill/>
-        </p:spPr>
-        <p:txBody>
-          <a:bodyPr wrap="none">
-            <a:spAutoFit/>
-          </a:bodyPr>
-          <a:lstStyle/>
-          <a:p>
-            <a:pPr>
-              <a:defRPr sz="800">
-                <a:solidFill>
-                  <a:srgbClr val="586370"/>
-                </a:solidFill>
-              </a:defRPr>
-            </a:pPr>
-            <a:r>
-              <a:t>Cyber Log Attack Detection | 8</a:t>
-            </a:r>
-          </a:p>
-        </p:txBody>
-      </p:sp>
-      <p:graphicFrame>
-        <p:nvGraphicFramePr>
-          <p:cNvPr id="5" name="Chart 4"/>
-          <p:cNvGraphicFramePr>
-            <a:graphicFrameLocks noGrp="1"/>
-          </p:cNvGraphicFramePr>
-          <p:nvPr/>
-        </p:nvGraphicFramePr>
-        <p:xfrm>
-          <a:off x="777240" y="1143000"/>
-          <a:ext cx="5715000" cy="4114800"/>
-        </p:xfrm>
-        <a:graphic>
-          <a:graphicData uri="http://schemas.openxmlformats.org/drawingml/2006/chart">
-            <c:chart xmlns:c="http://schemas.openxmlformats.org/drawingml/2006/chart" r:id="rId2"/>
-          </a:graphicData>
-        </a:graphic>
-      </p:graphicFrame>
-      <p:graphicFrame>
-        <p:nvGraphicFramePr>
-          <p:cNvPr id="6" name="Table 5"/>
-          <p:cNvGraphicFramePr>
-            <a:graphicFrameLocks noGrp="1"/>
-          </p:cNvGraphicFramePr>
-          <p:nvPr/>
-        </p:nvGraphicFramePr>
-        <p:xfrm>
-          <a:off x="6720840" y="1325880"/>
-          <a:ext cx="4846320" cy="2514600"/>
-        </p:xfrm>
-        <a:graphic>
-          <a:graphicData uri="http://schemas.openxmlformats.org/drawingml/2006/table">
-            <a:tbl>
-              <a:tblPr firstRow="1" bandRow="1">
-                <a:tableStyleId>{5C22544A-7EE6-4342-B048-85BDC9FD1C3A}</a:tableStyleId>
-              </a:tblPr>
-              <a:tblGrid>
-                <a:gridCol w="2423160"/>
-                <a:gridCol w="2423160"/>
-              </a:tblGrid>
-              <a:tr h="502920">
-                <a:tc>
-                  <a:txBody>
-                    <a:bodyPr/>
-                    <a:lstStyle/>
-                    <a:p>
-                      <a:pPr>
-                        <a:defRPr b="1" sz="1000">
-                          <a:solidFill>
-                            <a:srgbClr val="FFFFFF"/>
-                          </a:solidFill>
-                        </a:defRPr>
-                      </a:pPr>
-                      <a:r>
-                        <a:t>Decision</a:t>
-                      </a:r>
-                    </a:p>
-                  </a:txBody>
-                  <a:tcPr>
-                    <a:solidFill>
-                      <a:srgbClr val="2A6F97"/>
-                    </a:solidFill>
-                  </a:tcPr>
-                </a:tc>
-                <a:tc>
-                  <a:txBody>
-                    <a:bodyPr/>
-                    <a:lstStyle/>
-                    <a:p>
-                      <a:pPr>
-                        <a:defRPr b="1" sz="1000">
-                          <a:solidFill>
-                            <a:srgbClr val="FFFFFF"/>
-                          </a:solidFill>
-                        </a:defRPr>
-                      </a:pPr>
-                      <a:r>
-                        <a:t>Evidence</a:t>
-                      </a:r>
-                    </a:p>
-                  </a:txBody>
-                  <a:tcPr>
-                    <a:solidFill>
-                      <a:srgbClr val="2A6F97"/>
-                    </a:solidFill>
-                  </a:tcPr>
-                </a:tc>
-              </a:tr>
-              <a:tr h="502920">
-                <a:tc>
-                  <a:txBody>
-                    <a:bodyPr/>
-                    <a:lstStyle/>
-                    <a:p>
-                      <a:pPr>
-                        <a:defRPr sz="900">
-                          <a:solidFill>
-                            <a:srgbClr val="1C232B"/>
-                          </a:solidFill>
-                        </a:defRPr>
-                      </a:pPr>
-                      <a:r>
-                        <a:t>Binary</a:t>
-                      </a:r>
-                    </a:p>
-                  </a:txBody>
-                  <a:tcPr>
-                    <a:solidFill>
-                      <a:srgbClr val="FFFFFF"/>
-                    </a:solidFill>
-                  </a:tcPr>
-                </a:tc>
-                <a:tc>
-                  <a:txBody>
-                    <a:bodyPr/>
-                    <a:lstStyle/>
-                    <a:p>
-                      <a:pPr>
-                        <a:defRPr sz="900">
-                          <a:solidFill>
-                            <a:srgbClr val="1C232B"/>
-                          </a:solidFill>
-                        </a:defRPr>
-                      </a:pPr>
-                      <a:r>
-                        <a:t>Unified binary macro F1: 0.9929</a:t>
-                      </a:r>
-                    </a:p>
-                  </a:txBody>
-                  <a:tcPr>
-                    <a:solidFill>
-                      <a:srgbClr val="FFFFFF"/>
-                    </a:solidFill>
-                  </a:tcPr>
-                </a:tc>
-              </a:tr>
-              <a:tr h="502920">
-                <a:tc>
-                  <a:txBody>
-                    <a:bodyPr/>
-                    <a:lstStyle/>
-                    <a:p>
-                      <a:pPr>
-                        <a:defRPr sz="900">
-                          <a:solidFill>
-                            <a:srgbClr val="1C232B"/>
-                          </a:solidFill>
-                        </a:defRPr>
-                      </a:pPr>
-                      <a:r>
-                        <a:t>Category</a:t>
-                      </a:r>
-                    </a:p>
-                  </a:txBody>
-                  <a:tcPr>
-                    <a:solidFill>
-                      <a:srgbClr val="F7F9FA"/>
-                    </a:solidFill>
-                  </a:tcPr>
-                </a:tc>
-                <a:tc>
-                  <a:txBody>
-                    <a:bodyPr/>
-                    <a:lstStyle/>
-                    <a:p>
-                      <a:pPr>
-                        <a:defRPr sz="900">
-                          <a:solidFill>
-                            <a:srgbClr val="1C232B"/>
-                          </a:solidFill>
-                        </a:defRPr>
-                      </a:pPr>
-                      <a:r>
-                        <a:t>Unified category macro F1: 0.9447</a:t>
-                      </a:r>
-                    </a:p>
-                  </a:txBody>
-                  <a:tcPr>
-                    <a:solidFill>
-                      <a:srgbClr val="F7F9FA"/>
-                    </a:solidFill>
-                  </a:tcPr>
-                </a:tc>
-              </a:tr>
-              <a:tr h="502920">
-                <a:tc>
-                  <a:txBody>
-                    <a:bodyPr/>
-                    <a:lstStyle/>
-                    <a:p>
-                      <a:pPr>
-                        <a:defRPr sz="900">
-                          <a:solidFill>
-                            <a:srgbClr val="1C232B"/>
-                          </a:solidFill>
-                        </a:defRPr>
-                      </a:pPr>
-                      <a:r>
-                        <a:t>Specialists</a:t>
-                      </a:r>
-                    </a:p>
-                  </a:txBody>
-                  <a:tcPr>
-                    <a:solidFill>
-                      <a:srgbClr val="FFFFFF"/>
-                    </a:solidFill>
-                  </a:tcPr>
-                </a:tc>
-                <a:tc>
-                  <a:txBody>
-                    <a:bodyPr/>
-                    <a:lstStyle/>
-                    <a:p>
-                      <a:pPr>
-                        <a:defRPr sz="900">
-                          <a:solidFill>
-                            <a:srgbClr val="1C232B"/>
-                          </a:solidFill>
-                        </a:defRPr>
-                      </a:pPr>
-                      <a:r>
-                        <a:t>Web and firewall category specialists improved diagnosis</a:t>
-                      </a:r>
-                    </a:p>
-                  </a:txBody>
-                  <a:tcPr>
-                    <a:solidFill>
-                      <a:srgbClr val="FFFFFF"/>
-                    </a:solidFill>
-                  </a:tcPr>
-                </a:tc>
-              </a:tr>
-              <a:tr h="502920">
-                <a:tc>
-                  <a:txBody>
-                    <a:bodyPr/>
-                    <a:lstStyle/>
-                    <a:p>
-                      <a:pPr>
-                        <a:defRPr sz="900">
-                          <a:solidFill>
-                            <a:srgbClr val="1C232B"/>
-                          </a:solidFill>
-                        </a:defRPr>
-                      </a:pPr>
-                      <a:r>
-                        <a:t>Final</a:t>
-                      </a:r>
-                    </a:p>
-                  </a:txBody>
-                  <a:tcPr>
-                    <a:solidFill>
-                      <a:srgbClr val="F7F9FA"/>
-                    </a:solidFill>
-                  </a:tcPr>
-                </a:tc>
-                <a:tc>
-                  <a:txBody>
-                    <a:bodyPr/>
-                    <a:lstStyle/>
-                    <a:p>
-                      <a:pPr>
-                        <a:defRPr sz="900">
-                          <a:solidFill>
-                            <a:srgbClr val="1C232B"/>
-                          </a:solidFill>
-                        </a:defRPr>
-                      </a:pPr>
-                      <a:r>
-                        <a:t>Unified binary + specialist categories</a:t>
-                      </a:r>
-                    </a:p>
-                  </a:txBody>
-                  <a:tcPr>
-                    <a:solidFill>
-                      <a:srgbClr val="F7F9FA"/>
-                    </a:solidFill>
-                  </a:tcPr>
-                </a:tc>
-              </a:tr>
-            </a:tbl>
-          </a:graphicData>
-        </a:graphic>
-      </p:graphicFrame>
-      <p:sp>
-        <p:nvSpPr>
-          <p:cNvPr id="7" name="TextBox 6"/>
-          <p:cNvSpPr txBox="1"/>
-          <p:nvPr/>
-        </p:nvSpPr>
-        <p:spPr>
-          <a:xfrm>
-            <a:off x="6812280" y="4160520"/>
-            <a:ext cx="4572000" cy="731520"/>
-          </a:xfrm>
-          <a:prstGeom prst="rect">
-            <a:avLst/>
-          </a:prstGeom>
-          <a:noFill/>
-        </p:spPr>
-        <p:txBody>
-          <a:bodyPr wrap="none">
-            <a:spAutoFit/>
-          </a:bodyPr>
-          <a:lstStyle/>
-          <a:p>
-            <a:pPr>
-              <a:spcAft>
-                <a:spcPts val="800"/>
-              </a:spcAft>
-              <a:defRPr sz="1600">
-                <a:solidFill>
-                  <a:srgbClr val="1C232B"/>
-                </a:solidFill>
-              </a:defRPr>
-            </a:pPr>
-            <a:r>
-              <a:t>Metrics prove pipeline behavior on current data, not production readiness.</a:t>
-            </a:r>
-          </a:p>
-        </p:txBody>
-      </p:sp>
-    </p:spTree>
-  </p:cSld>
-  <p:clrMapOvr>
-    <a:masterClrMapping/>
-  </p:clrMapOvr>
-</p:sld>
-</file>
-
-<file path=ppt/slides/slide9.xml><?xml version="1.0" encoding="utf-8"?>
-<p:sld xmlns:a="http://schemas.openxmlformats.org/drawingml/2006/main" xmlns:p="http://schemas.openxmlformats.org/presentationml/2006/main" xmlns:r="http://schemas.openxmlformats.org/officeDocument/2006/relationships">
-  <p:cSld>
-    <p:spTree>
-      <p:nvGrpSpPr>
-        <p:cNvPr id="1" name=""/>
-        <p:cNvGrpSpPr/>
-        <p:nvPr/>
-      </p:nvGrpSpPr>
-      <p:grpSpPr/>
-      <p:sp>
-        <p:nvSpPr>
-          <p:cNvPr id="2" name="TextBox 1"/>
-          <p:cNvSpPr txBox="1"/>
-          <p:nvPr/>
-        </p:nvSpPr>
-        <p:spPr>
-          <a:xfrm>
-            <a:off x="502920" y="320040"/>
-            <a:ext cx="11155680" cy="548640"/>
-          </a:xfrm>
-          <a:prstGeom prst="rect">
-            <a:avLst/>
-          </a:prstGeom>
-          <a:noFill/>
-        </p:spPr>
-        <p:txBody>
-          <a:bodyPr wrap="none">
-            <a:spAutoFit/>
-          </a:bodyPr>
-          <a:lstStyle/>
-          <a:p>
-            <a:pPr>
-              <a:defRPr sz="2800" b="1">
-                <a:solidFill>
-                  <a:srgbClr val="1C232B"/>
-                </a:solidFill>
-              </a:defRPr>
-            </a:pPr>
-            <a:r>
-              <a:t>Scenario Demo</a:t>
-            </a:r>
-          </a:p>
-        </p:txBody>
-      </p:sp>
-      <p:sp>
-        <p:nvSpPr>
-          <p:cNvPr id="3" name="Rectangle 2"/>
-          <p:cNvSpPr/>
-          <p:nvPr/>
-        </p:nvSpPr>
-        <p:spPr>
-          <a:xfrm>
-            <a:off x="0" y="6556248"/>
-            <a:ext cx="12188952" cy="36576"/>
-          </a:xfrm>
-          <a:prstGeom prst="rect">
-            <a:avLst/>
-          </a:prstGeom>
-          <a:solidFill>
-            <a:srgbClr val="D2D8DE"/>
-          </a:solidFill>
-          <a:ln>
-            <a:noFill/>
-          </a:ln>
-        </p:spPr>
-        <p:style>
-          <a:lnRef idx="1">
-            <a:schemeClr val="accent1"/>
-          </a:lnRef>
-          <a:fillRef idx="3">
-            <a:schemeClr val="accent1"/>
-          </a:fillRef>
-          <a:effectRef idx="2">
-            <a:schemeClr val="accent1"/>
-          </a:effectRef>
-          <a:fontRef idx="minor">
-            <a:schemeClr val="lt1"/>
-          </a:fontRef>
-        </p:style>
-        <p:txBody>
-          <a:bodyPr rtlCol="0" anchor="ctr"/>
-          <a:lstStyle/>
-          <a:p>
-            <a:pPr algn="ctr"/>
-          </a:p>
-        </p:txBody>
-      </p:sp>
-      <p:sp>
-        <p:nvSpPr>
-          <p:cNvPr id="4" name="TextBox 3"/>
-          <p:cNvSpPr txBox="1"/>
-          <p:nvPr/>
-        </p:nvSpPr>
-        <p:spPr>
-          <a:xfrm>
-            <a:off x="502920" y="6601968"/>
-            <a:ext cx="11155680" cy="228600"/>
-          </a:xfrm>
-          <a:prstGeom prst="rect">
-            <a:avLst/>
-          </a:prstGeom>
-          <a:noFill/>
-        </p:spPr>
-        <p:txBody>
-          <a:bodyPr wrap="none">
-            <a:spAutoFit/>
-          </a:bodyPr>
-          <a:lstStyle/>
-          <a:p>
-            <a:pPr>
-              <a:defRPr sz="800">
-                <a:solidFill>
-                  <a:srgbClr val="586370"/>
-                </a:solidFill>
-              </a:defRPr>
-            </a:pPr>
-            <a:r>
-              <a:t>Cyber Log Attack Detection | 9</a:t>
-            </a:r>
-          </a:p>
-        </p:txBody>
-      </p:sp>
-      <p:graphicFrame>
-        <p:nvGraphicFramePr>
-          <p:cNvPr id="5" name="Table 4"/>
-          <p:cNvGraphicFramePr>
-            <a:graphicFrameLocks noGrp="1"/>
-          </p:cNvGraphicFramePr>
-          <p:nvPr/>
-        </p:nvGraphicFramePr>
-        <p:xfrm>
-          <a:off x="822960" y="1234440"/>
-          <a:ext cx="4754880" cy="2331720"/>
-        </p:xfrm>
-        <a:graphic>
-          <a:graphicData uri="http://schemas.openxmlformats.org/drawingml/2006/table">
-            <a:tbl>
-              <a:tblPr firstRow="1" bandRow="1">
-                <a:tableStyleId>{5C22544A-7EE6-4342-B048-85BDC9FD1C3A}</a:tableStyleId>
-              </a:tblPr>
-              <a:tblGrid>
-                <a:gridCol w="2377440"/>
-                <a:gridCol w="2377440"/>
-              </a:tblGrid>
-              <a:tr h="388620">
-                <a:tc>
-                  <a:txBody>
-                    <a:bodyPr/>
-                    <a:lstStyle/>
-                    <a:p>
-                      <a:pPr>
-                        <a:defRPr b="1" sz="1000">
-                          <a:solidFill>
-                            <a:srgbClr val="FFFFFF"/>
-                          </a:solidFill>
-                        </a:defRPr>
-                      </a:pPr>
-                      <a:r>
-                        <a:t>Metric</a:t>
-                      </a:r>
-                    </a:p>
-                  </a:txBody>
-                  <a:tcPr>
-                    <a:solidFill>
-                      <a:srgbClr val="2A6F97"/>
-                    </a:solidFill>
-                  </a:tcPr>
-                </a:tc>
-                <a:tc>
-                  <a:txBody>
-                    <a:bodyPr/>
-                    <a:lstStyle/>
-                    <a:p>
-                      <a:pPr>
-                        <a:defRPr b="1" sz="1000">
-                          <a:solidFill>
-                            <a:srgbClr val="FFFFFF"/>
-                          </a:solidFill>
-                        </a:defRPr>
-                      </a:pPr>
-                      <a:r>
-                        <a:t>Value</a:t>
-                      </a:r>
-                    </a:p>
-                  </a:txBody>
-                  <a:tcPr>
-                    <a:solidFill>
-                      <a:srgbClr val="2A6F97"/>
-                    </a:solidFill>
-                  </a:tcPr>
-                </a:tc>
-              </a:tr>
-              <a:tr h="388620">
-                <a:tc>
-                  <a:txBody>
-                    <a:bodyPr/>
-                    <a:lstStyle/>
-                    <a:p>
-                      <a:pPr>
-                        <a:defRPr sz="900">
-                          <a:solidFill>
-                            <a:srgbClr val="1C232B"/>
-                          </a:solidFill>
-                        </a:defRPr>
-                      </a:pPr>
-                      <a:r>
-                        <a:t>Rows scored</a:t>
-                      </a:r>
-                    </a:p>
-                  </a:txBody>
-                  <a:tcPr>
-                    <a:solidFill>
-                      <a:srgbClr val="FFFFFF"/>
-                    </a:solidFill>
-                  </a:tcPr>
-                </a:tc>
-                <a:tc>
-                  <a:txBody>
-                    <a:bodyPr/>
-                    <a:lstStyle/>
-                    <a:p>
-                      <a:pPr>
-                        <a:defRPr sz="900">
-                          <a:solidFill>
-                            <a:srgbClr val="1C232B"/>
-                          </a:solidFill>
-                        </a:defRPr>
-                      </a:pPr>
-                      <a:r>
-                        <a:t>18</a:t>
-                      </a:r>
-                    </a:p>
-                  </a:txBody>
-                  <a:tcPr>
-                    <a:solidFill>
-                      <a:srgbClr val="FFFFFF"/>
-                    </a:solidFill>
-                  </a:tcPr>
-                </a:tc>
-              </a:tr>
-              <a:tr h="388620">
-                <a:tc>
-                  <a:txBody>
-                    <a:bodyPr/>
-                    <a:lstStyle/>
-                    <a:p>
-                      <a:pPr>
-                        <a:defRPr sz="900">
-                          <a:solidFill>
-                            <a:srgbClr val="1C232B"/>
-                          </a:solidFill>
-                        </a:defRPr>
-                      </a:pPr>
-                      <a:r>
-                        <a:t>Expected attacks</a:t>
-                      </a:r>
-                    </a:p>
-                  </a:txBody>
-                  <a:tcPr>
-                    <a:solidFill>
-                      <a:srgbClr val="F7F9FA"/>
-                    </a:solidFill>
-                  </a:tcPr>
-                </a:tc>
-                <a:tc>
-                  <a:txBody>
-                    <a:bodyPr/>
-                    <a:lstStyle/>
-                    <a:p>
-                      <a:pPr>
-                        <a:defRPr sz="900">
-                          <a:solidFill>
-                            <a:srgbClr val="1C232B"/>
-                          </a:solidFill>
-                        </a:defRPr>
-                      </a:pPr>
-                      <a:r>
-                        <a:t>12</a:t>
-                      </a:r>
-                    </a:p>
-                  </a:txBody>
-                  <a:tcPr>
-                    <a:solidFill>
-                      <a:srgbClr val="F7F9FA"/>
-                    </a:solidFill>
-                  </a:tcPr>
-                </a:tc>
-              </a:tr>
-              <a:tr h="388620">
-                <a:tc>
-                  <a:txBody>
-                    <a:bodyPr/>
-                    <a:lstStyle/>
-                    <a:p>
-                      <a:pPr>
-                        <a:defRPr sz="900">
-                          <a:solidFill>
-                            <a:srgbClr val="1C232B"/>
-                          </a:solidFill>
-                        </a:defRPr>
-                      </a:pPr>
-                      <a:r>
-                        <a:t>Predicted attacks</a:t>
-                      </a:r>
-                    </a:p>
-                  </a:txBody>
-                  <a:tcPr>
-                    <a:solidFill>
-                      <a:srgbClr val="FFFFFF"/>
-                    </a:solidFill>
-                  </a:tcPr>
-                </a:tc>
-                <a:tc>
-                  <a:txBody>
-                    <a:bodyPr/>
-                    <a:lstStyle/>
-                    <a:p>
-                      <a:pPr>
-                        <a:defRPr sz="900">
-                          <a:solidFill>
-                            <a:srgbClr val="1C232B"/>
-                          </a:solidFill>
-                        </a:defRPr>
-                      </a:pPr>
-                      <a:r>
-                        <a:t>11</a:t>
-                      </a:r>
-                    </a:p>
-                  </a:txBody>
-                  <a:tcPr>
-                    <a:solidFill>
-                      <a:srgbClr val="FFFFFF"/>
-                    </a:solidFill>
-                  </a:tcPr>
-                </a:tc>
-              </a:tr>
-              <a:tr h="388620">
-                <a:tc>
-                  <a:txBody>
-                    <a:bodyPr/>
-                    <a:lstStyle/>
-                    <a:p>
-                      <a:pPr>
-                        <a:defRPr sz="900">
-                          <a:solidFill>
-                            <a:srgbClr val="1C232B"/>
-                          </a:solidFill>
-                        </a:defRPr>
-                      </a:pPr>
-                      <a:r>
-                        <a:t>Binary accuracy</a:t>
-                      </a:r>
-                    </a:p>
-                  </a:txBody>
-                  <a:tcPr>
-                    <a:solidFill>
-                      <a:srgbClr val="F7F9FA"/>
-                    </a:solidFill>
-                  </a:tcPr>
-                </a:tc>
-                <a:tc>
-                  <a:txBody>
-                    <a:bodyPr/>
-                    <a:lstStyle/>
-                    <a:p>
-                      <a:pPr>
-                        <a:defRPr sz="900">
-                          <a:solidFill>
-                            <a:srgbClr val="1C232B"/>
-                          </a:solidFill>
-                        </a:defRPr>
-                      </a:pPr>
-                      <a:r>
-                        <a:t>0.944</a:t>
-                      </a:r>
-                    </a:p>
-                  </a:txBody>
-                  <a:tcPr>
-                    <a:solidFill>
-                      <a:srgbClr val="F7F9FA"/>
-                    </a:solidFill>
-                  </a:tcPr>
-                </a:tc>
-              </a:tr>
-              <a:tr h="388620">
-                <a:tc>
-                  <a:txBody>
-                    <a:bodyPr/>
-                    <a:lstStyle/>
-                    <a:p>
-                      <a:pPr>
-                        <a:defRPr sz="900">
-                          <a:solidFill>
-                            <a:srgbClr val="1C232B"/>
-                          </a:solidFill>
-                        </a:defRPr>
-                      </a:pPr>
-                      <a:r>
-                        <a:t>Category accuracy on attacks</a:t>
-                      </a:r>
-                    </a:p>
-                  </a:txBody>
-                  <a:tcPr>
-                    <a:solidFill>
-                      <a:srgbClr val="FFFFFF"/>
-                    </a:solidFill>
-                  </a:tcPr>
-                </a:tc>
-                <a:tc>
-                  <a:txBody>
-                    <a:bodyPr/>
-                    <a:lstStyle/>
-                    <a:p>
-                      <a:pPr>
-                        <a:defRPr sz="900">
-                          <a:solidFill>
-                            <a:srgbClr val="1C232B"/>
-                          </a:solidFill>
-                        </a:defRPr>
-                      </a:pPr>
-                      <a:r>
-                        <a:t>0.833</a:t>
-                      </a:r>
-                    </a:p>
-                  </a:txBody>
-                  <a:tcPr>
-                    <a:solidFill>
-                      <a:srgbClr val="FFFFFF"/>
-                    </a:solidFill>
-                  </a:tcPr>
-                </a:tc>
-              </a:tr>
-            </a:tbl>
-          </a:graphicData>
-        </a:graphic>
-      </p:graphicFrame>
-      <p:sp>
-        <p:nvSpPr>
-          <p:cNvPr id="6" name="TextBox 5"/>
-          <p:cNvSpPr txBox="1"/>
-          <p:nvPr/>
-        </p:nvSpPr>
-        <p:spPr>
-          <a:xfrm>
-            <a:off x="6126480" y="1325880"/>
-            <a:ext cx="5303520" cy="2423160"/>
-          </a:xfrm>
-          <a:prstGeom prst="rect">
-            <a:avLst/>
-          </a:prstGeom>
-          <a:noFill/>
-        </p:spPr>
-        <p:txBody>
-          <a:bodyPr wrap="none">
-            <a:spAutoFit/>
-          </a:bodyPr>
-          <a:lstStyle/>
-          <a:p>
-            <a:pPr>
-              <a:spcAft>
-                <a:spcPts val="800"/>
-              </a:spcAft>
-              <a:defRPr sz="1700">
-                <a:solidFill>
-                  <a:srgbClr val="1C232B"/>
-                </a:solidFill>
-              </a:defRPr>
-            </a:pPr>
-            <a:r>
-              <a:t>One SQL injection was categorized as XSS.</a:t>
-            </a:r>
-          </a:p>
-          <a:p>
-            <a:pPr>
-              <a:spcAft>
-                <a:spcPts val="800"/>
-              </a:spcAft>
-              <a:defRPr sz="1700">
-                <a:solidFill>
-                  <a:srgbClr val="1C232B"/>
-                </a:solidFill>
-              </a:defRPr>
-            </a:pPr>
-            <a:r>
-              <a:t>One suspicious outbound firewall event was missed by the binary gate.</a:t>
-            </a:r>
-          </a:p>
-          <a:p>
-            <a:pPr>
-              <a:spcAft>
-                <a:spcPts val="800"/>
-              </a:spcAft>
-              <a:defRPr sz="1700">
-                <a:solidFill>
-                  <a:srgbClr val="1C232B"/>
-                </a:solidFill>
-              </a:defRPr>
-            </a:pPr>
-            <a:r>
-              <a:t>These visible mistakes are useful: they show where more real data and better windows are needed.</a:t>
             </a:r>
           </a:p>
         </p:txBody>

</xml_diff>